<commit_message>
updated the PPT, Readme and lauch json
</commit_message>
<xml_diff>
--- a/docs/AgentForge-PresentationV11.pptx
+++ b/docs/AgentForge-PresentationV11.pptx
@@ -31,6 +31,7 @@
     <p:sldId id="279" r:id="rId25"/>
     <p:sldId id="280" r:id="rId26"/>
     <p:sldId id="282" r:id="rId27"/>
+    <p:sldId id="301" r:id="rId51"/>
     <p:sldId id="283" r:id="rId28"/>
     <p:sldId id="284" r:id="rId29"/>
     <p:sldId id="293" r:id="rId30"/>
@@ -6821,7 +6822,7 @@
                   <a:srgbClr val="CBD5E1"/>
                 </a:solidFill>
               </a:rPr>
-              <a:t>▸ Azure OpenAI GPT-5.4-mini + GPT-5.4-mini</a:t>
+              <a:t>▸ Azure OpenAI, Google Gemini, local LM Studio</a:t>
             </a:r>
           </a:p>
         </p:txBody>
@@ -19604,7 +19605,7 @@
                   <a:srgbClr val="CBD5E1"/>
                 </a:solidFill>
               </a:rPr>
-              <a:t>▸ Control Plane (live agent modification) + Local LLM support (LM Studio, per-agent)</a:t>
+              <a:t>▸ Control Plane (live agent modification) + multi-provider LLMs (LM Studio + Google Gemini, per-agent / per-feature)</a:t>
             </a:r>
           </a:p>
         </p:txBody>
@@ -38279,7 +38280,7 @@
 </file>
 
 <file path=ppt/slides/slide36.xml><?xml version="1.0" encoding="utf-8"?>
-<p:sld xmlns:a="http://schemas.openxmlformats.org/drawingml/2006/main" xmlns:r="http://schemas.openxmlformats.org/officeDocument/2006/relationships" xmlns:p="http://schemas.openxmlformats.org/presentationml/2006/main">
+<p:sld xmlns:a="http://schemas.openxmlformats.org/drawingml/2006/main" xmlns:p="http://schemas.openxmlformats.org/presentationml/2006/main" xmlns:r="http://schemas.openxmlformats.org/officeDocument/2006/relationships">
   <p:cSld>
     <p:spTree>
       <p:nvGrpSpPr>
@@ -38287,14 +38288,7 @@
         <p:cNvGrpSpPr/>
         <p:nvPr/>
       </p:nvGrpSpPr>
-      <p:grpSpPr>
-        <a:xfrm>
-          <a:off x="0" y="0"/>
-          <a:ext cx="0" cy="0"/>
-          <a:chOff x="0" y="0"/>
-          <a:chExt cx="0" cy="0"/>
-        </a:xfrm>
-      </p:grpSpPr>
+      <p:grpSpPr/>
       <p:sp>
         <p:nvSpPr>
           <p:cNvPr id="2" name="Rectangle 1"/>
@@ -38304,7 +38298,7 @@
         <p:spPr>
           <a:xfrm>
             <a:off x="0" y="0"/>
-            <a:ext cx="12188825" cy="6858000"/>
+            <a:ext cx="12188952" cy="6858000"/>
           </a:xfrm>
           <a:prstGeom prst="rect">
             <a:avLst/>
@@ -38336,7 +38330,6 @@
           <a:lstStyle/>
           <a:p>
             <a:pPr algn="ctr"/>
-            <a:endParaRPr/>
           </a:p>
         </p:txBody>
       </p:sp>
@@ -38349,7 +38342,7 @@
         <p:spPr>
           <a:xfrm>
             <a:off x="0" y="73152"/>
-            <a:ext cx="12188825" cy="45720"/>
+            <a:ext cx="12188952" cy="45720"/>
           </a:xfrm>
           <a:prstGeom prst="rect">
             <a:avLst/>
@@ -38381,7 +38374,6 @@
           <a:lstStyle/>
           <a:p>
             <a:pPr algn="ctr"/>
-            <a:endParaRPr/>
           </a:p>
         </p:txBody>
       </p:sp>
@@ -38407,13 +38399,14 @@
           </a:bodyPr>
           <a:lstStyle/>
           <a:p>
-            <a:r>
-              <a:rPr sz="2600" b="1">
+            <a:pPr algn="l"/>
+            <a:r>
+              <a:rPr sz="2400" b="1">
                 <a:solidFill>
                   <a:srgbClr val="FFFFFF"/>
                 </a:solidFill>
               </a:rPr>
-              <a:t>How To Use: Visual Builder — Templates &amp; Auto-Build</a:t>
+              <a:t>Honest UI Audit &amp; a Real Production Bug — What Changed</a:t>
             </a:r>
           </a:p>
         </p:txBody>
@@ -38426,7 +38419,601 @@
         </p:nvSpPr>
         <p:spPr>
           <a:xfrm>
-            <a:off x="11731752" y="6492240"/>
+            <a:off x="457200" y="868680"/>
+            <a:ext cx="11247120" cy="548640"/>
+          </a:xfrm>
+          <a:prstGeom prst="rect">
+            <a:avLst/>
+          </a:prstGeom>
+          <a:noFill/>
+        </p:spPr>
+        <p:txBody>
+          <a:bodyPr wrap="square">
+            <a:spAutoFit/>
+          </a:bodyPr>
+          <a:lstStyle/>
+          <a:p>
+            <a:pPr algn="l"/>
+            <a:r>
+              <a:rPr sz="1200" b="0">
+                <a:solidFill>
+                  <a:srgbClr val="CBD5E1"/>
+                </a:solidFill>
+              </a:rPr>
+              <a:t>A page-by-page pass asking “is this actually wired to the backend, or does it just look like it is?” — found three independent fake integration surfaces, a fully non-functional publish loop, and one genuine crash silently zeroing out two dashboards.</a:t>
+            </a:r>
+          </a:p>
+        </p:txBody>
+      </p:sp>
+      <p:sp>
+        <p:nvSpPr>
+          <p:cNvPr id="6" name="Rectangle 5"/>
+          <p:cNvSpPr/>
+          <p:nvPr/>
+        </p:nvSpPr>
+        <p:spPr>
+          <a:xfrm>
+            <a:off x="365760" y="1536192"/>
+            <a:ext cx="73152" cy="777240"/>
+          </a:xfrm>
+          <a:prstGeom prst="rect">
+            <a:avLst/>
+          </a:prstGeom>
+          <a:solidFill>
+            <a:srgbClr val="606EF5"/>
+          </a:solidFill>
+          <a:ln>
+            <a:noFill/>
+          </a:ln>
+          <a:effectLst/>
+        </p:spPr>
+        <p:style>
+          <a:lnRef idx="1">
+            <a:schemeClr val="accent1"/>
+          </a:lnRef>
+          <a:fillRef idx="3">
+            <a:schemeClr val="accent1"/>
+          </a:fillRef>
+          <a:effectRef idx="2">
+            <a:schemeClr val="accent1"/>
+          </a:effectRef>
+          <a:fontRef idx="minor">
+            <a:schemeClr val="lt1"/>
+          </a:fontRef>
+        </p:style>
+        <p:txBody>
+          <a:bodyPr rtlCol="0" anchor="ctr"/>
+          <a:lstStyle/>
+          <a:p>
+            <a:pPr algn="ctr"/>
+          </a:p>
+        </p:txBody>
+      </p:sp>
+      <p:sp>
+        <p:nvSpPr>
+          <p:cNvPr id="7" name="TextBox 6"/>
+          <p:cNvSpPr txBox="1"/>
+          <p:nvPr/>
+        </p:nvSpPr>
+        <p:spPr>
+          <a:xfrm>
+            <a:off x="594360" y="1554480"/>
+            <a:ext cx="10972800" cy="365760"/>
+          </a:xfrm>
+          <a:prstGeom prst="rect">
+            <a:avLst/>
+          </a:prstGeom>
+          <a:noFill/>
+        </p:spPr>
+        <p:txBody>
+          <a:bodyPr wrap="square">
+            <a:spAutoFit/>
+          </a:bodyPr>
+          <a:lstStyle/>
+          <a:p>
+            <a:pPr algn="l"/>
+            <a:r>
+              <a:rPr sz="1400" b="1">
+                <a:solidFill>
+                  <a:srgbClr val="606EF5"/>
+                </a:solidFill>
+              </a:rPr>
+              <a:t>🎯  Deterministic Branch Input Matching</a:t>
+            </a:r>
+          </a:p>
+        </p:txBody>
+      </p:sp>
+      <p:sp>
+        <p:nvSpPr>
+          <p:cNvPr id="8" name="TextBox 7"/>
+          <p:cNvSpPr txBox="1"/>
+          <p:nvPr/>
+        </p:nvSpPr>
+        <p:spPr>
+          <a:xfrm>
+            <a:off x="594360" y="1920303"/>
+            <a:ext cx="11064240" cy="457200"/>
+          </a:xfrm>
+          <a:prstGeom prst="rect">
+            <a:avLst/>
+          </a:prstGeom>
+          <a:noFill/>
+        </p:spPr>
+        <p:txBody>
+          <a:bodyPr wrap="square">
+            <a:spAutoFit/>
+          </a:bodyPr>
+          <a:lstStyle/>
+          <a:p>
+            <a:pPr algn="l"/>
+            <a:r>
+              <a:rPr sz="1050" b="0">
+                <a:solidFill>
+                  <a:srgbClr val="CBD5E1"/>
+                </a:solidFill>
+              </a:rPr>
+              <a:t>The Run modal's example input now regenerates to match whichever router branch is force-selected (e.g. Critical vs Routine) instead of leaving a stale, narratively mismatched example — a new target_label parameter on /suggest-input asks the LLM to write an example that specifically satisfies that router node's own classification criteria.</a:t>
+            </a:r>
+          </a:p>
+        </p:txBody>
+      </p:sp>
+      <p:sp>
+        <p:nvSpPr>
+          <p:cNvPr id="9" name="Rectangle 8"/>
+          <p:cNvSpPr/>
+          <p:nvPr/>
+        </p:nvSpPr>
+        <p:spPr>
+          <a:xfrm>
+            <a:off x="365760" y="2432304"/>
+            <a:ext cx="73152" cy="777240"/>
+          </a:xfrm>
+          <a:prstGeom prst="rect">
+            <a:avLst/>
+          </a:prstGeom>
+          <a:solidFill>
+            <a:srgbClr val="606EF5"/>
+          </a:solidFill>
+          <a:ln>
+            <a:noFill/>
+          </a:ln>
+          <a:effectLst/>
+        </p:spPr>
+        <p:style>
+          <a:lnRef idx="1">
+            <a:schemeClr val="accent1"/>
+          </a:lnRef>
+          <a:fillRef idx="3">
+            <a:schemeClr val="accent1"/>
+          </a:fillRef>
+          <a:effectRef idx="2">
+            <a:schemeClr val="accent1"/>
+          </a:effectRef>
+          <a:fontRef idx="minor">
+            <a:schemeClr val="lt1"/>
+          </a:fontRef>
+        </p:style>
+        <p:txBody>
+          <a:bodyPr rtlCol="0" anchor="ctr"/>
+          <a:lstStyle/>
+          <a:p>
+            <a:pPr algn="ctr"/>
+          </a:p>
+        </p:txBody>
+      </p:sp>
+      <p:sp>
+        <p:nvSpPr>
+          <p:cNvPr id="10" name="TextBox 9"/>
+          <p:cNvSpPr txBox="1"/>
+          <p:nvPr/>
+        </p:nvSpPr>
+        <p:spPr>
+          <a:xfrm>
+            <a:off x="594360" y="2450592"/>
+            <a:ext cx="10972800" cy="365760"/>
+          </a:xfrm>
+          <a:prstGeom prst="rect">
+            <a:avLst/>
+          </a:prstGeom>
+          <a:noFill/>
+        </p:spPr>
+        <p:txBody>
+          <a:bodyPr wrap="square">
+            <a:spAutoFit/>
+          </a:bodyPr>
+          <a:lstStyle/>
+          <a:p>
+            <a:pPr algn="l"/>
+            <a:r>
+              <a:rPr sz="1400" b="1">
+                <a:solidFill>
+                  <a:srgbClr val="606EF5"/>
+                </a:solidFill>
+              </a:rPr>
+              <a:t>🏷️  Found: 3 Independent Fake “Connect a Tool” Surfaces</a:t>
+            </a:r>
+          </a:p>
+        </p:txBody>
+      </p:sp>
+      <p:sp>
+        <p:nvSpPr>
+          <p:cNvPr id="11" name="TextBox 10"/>
+          <p:cNvSpPr txBox="1"/>
+          <p:nvPr/>
+        </p:nvSpPr>
+        <p:spPr>
+          <a:xfrm>
+            <a:off x="594360" y="2816415"/>
+            <a:ext cx="11064240" cy="457200"/>
+          </a:xfrm>
+          <a:prstGeom prst="rect">
+            <a:avLst/>
+          </a:prstGeom>
+          <a:noFill/>
+        </p:spPr>
+        <p:txBody>
+          <a:bodyPr wrap="square">
+            <a:spAutoFit/>
+          </a:bodyPr>
+          <a:lstStyle/>
+          <a:p>
+            <a:pPr algn="l"/>
+            <a:r>
+              <a:rPr sz="1050" b="0">
+                <a:solidFill>
+                  <a:srgbClr val="CBD5E1"/>
+                </a:solidFill>
+              </a:rPr>
+              <a:t>Home's Connect modal, Marketplace's Tool Integrations tab, and Agent Studio's tool checkboxes each silently did nothing — three separate, unsynchronized implementations of the same idea, none wired to any real OAuth flow or API credential. All three now carry an honest “not yet active” label instead of implying real access.</a:t>
+            </a:r>
+          </a:p>
+        </p:txBody>
+      </p:sp>
+      <p:sp>
+        <p:nvSpPr>
+          <p:cNvPr id="12" name="Rectangle 11"/>
+          <p:cNvSpPr/>
+          <p:nvPr/>
+        </p:nvSpPr>
+        <p:spPr>
+          <a:xfrm>
+            <a:off x="365760" y="3328416"/>
+            <a:ext cx="73152" cy="777240"/>
+          </a:xfrm>
+          <a:prstGeom prst="rect">
+            <a:avLst/>
+          </a:prstGeom>
+          <a:solidFill>
+            <a:srgbClr val="606EF5"/>
+          </a:solidFill>
+          <a:ln>
+            <a:noFill/>
+          </a:ln>
+          <a:effectLst/>
+        </p:spPr>
+        <p:style>
+          <a:lnRef idx="1">
+            <a:schemeClr val="accent1"/>
+          </a:lnRef>
+          <a:fillRef idx="3">
+            <a:schemeClr val="accent1"/>
+          </a:fillRef>
+          <a:effectRef idx="2">
+            <a:schemeClr val="accent1"/>
+          </a:effectRef>
+          <a:fontRef idx="minor">
+            <a:schemeClr val="lt1"/>
+          </a:fontRef>
+        </p:style>
+        <p:txBody>
+          <a:bodyPr rtlCol="0" anchor="ctr"/>
+          <a:lstStyle/>
+          <a:p>
+            <a:pPr algn="ctr"/>
+          </a:p>
+        </p:txBody>
+      </p:sp>
+      <p:sp>
+        <p:nvSpPr>
+          <p:cNvPr id="13" name="TextBox 12"/>
+          <p:cNvSpPr txBox="1"/>
+          <p:nvPr/>
+        </p:nvSpPr>
+        <p:spPr>
+          <a:xfrm>
+            <a:off x="594360" y="3346704"/>
+            <a:ext cx="10972800" cy="365760"/>
+          </a:xfrm>
+          <a:prstGeom prst="rect">
+            <a:avLst/>
+          </a:prstGeom>
+          <a:noFill/>
+        </p:spPr>
+        <p:txBody>
+          <a:bodyPr wrap="square">
+            <a:spAutoFit/>
+          </a:bodyPr>
+          <a:lstStyle/>
+          <a:p>
+            <a:pPr algn="l"/>
+            <a:r>
+              <a:rPr sz="1400" b="1">
+                <a:solidFill>
+                  <a:srgbClr val="606EF5"/>
+                </a:solidFill>
+              </a:rPr>
+              <a:t>🗑️  Retired the Publish → Marketplace → Install Loop</a:t>
+            </a:r>
+          </a:p>
+        </p:txBody>
+      </p:sp>
+      <p:sp>
+        <p:nvSpPr>
+          <p:cNvPr id="14" name="TextBox 13"/>
+          <p:cNvSpPr txBox="1"/>
+          <p:nvPr/>
+        </p:nvSpPr>
+        <p:spPr>
+          <a:xfrm>
+            <a:off x="594360" y="3712527"/>
+            <a:ext cx="11064240" cy="457200"/>
+          </a:xfrm>
+          <a:prstGeom prst="rect">
+            <a:avLst/>
+          </a:prstGeom>
+          <a:noFill/>
+        </p:spPr>
+        <p:txBody>
+          <a:bodyPr wrap="square">
+            <a:spAutoFit/>
+          </a:bodyPr>
+          <a:lstStyle/>
+          <a:p>
+            <a:pPr algn="l"/>
+            <a:r>
+              <a:rPr sz="1050" b="0">
+                <a:solidFill>
+                  <a:srgbClr val="CBD5E1"/>
+                </a:solidFill>
+              </a:rPr>
+              <a:t>Agent Studio's “Publish to Marketplace” button and Marketplace's “Published Agents” tab formed a closed, browser-local loop — both read/wrote the same localStorage key, never touched the backend, and shared nothing across users or even across browsers on the same machine. Removed entirely rather than left half-working.</a:t>
+            </a:r>
+          </a:p>
+        </p:txBody>
+      </p:sp>
+      <p:sp>
+        <p:nvSpPr>
+          <p:cNvPr id="15" name="Rectangle 14"/>
+          <p:cNvSpPr/>
+          <p:nvPr/>
+        </p:nvSpPr>
+        <p:spPr>
+          <a:xfrm>
+            <a:off x="365760" y="4224528"/>
+            <a:ext cx="73152" cy="777240"/>
+          </a:xfrm>
+          <a:prstGeom prst="rect">
+            <a:avLst/>
+          </a:prstGeom>
+          <a:solidFill>
+            <a:srgbClr val="606EF5"/>
+          </a:solidFill>
+          <a:ln>
+            <a:noFill/>
+          </a:ln>
+          <a:effectLst/>
+        </p:spPr>
+        <p:style>
+          <a:lnRef idx="1">
+            <a:schemeClr val="accent1"/>
+          </a:lnRef>
+          <a:fillRef idx="3">
+            <a:schemeClr val="accent1"/>
+          </a:fillRef>
+          <a:effectRef idx="2">
+            <a:schemeClr val="accent1"/>
+          </a:effectRef>
+          <a:fontRef idx="minor">
+            <a:schemeClr val="lt1"/>
+          </a:fontRef>
+        </p:style>
+        <p:txBody>
+          <a:bodyPr rtlCol="0" anchor="ctr"/>
+          <a:lstStyle/>
+          <a:p>
+            <a:pPr algn="ctr"/>
+          </a:p>
+        </p:txBody>
+      </p:sp>
+      <p:sp>
+        <p:nvSpPr>
+          <p:cNvPr id="16" name="TextBox 15"/>
+          <p:cNvSpPr txBox="1"/>
+          <p:nvPr/>
+        </p:nvSpPr>
+        <p:spPr>
+          <a:xfrm>
+            <a:off x="594360" y="4242816"/>
+            <a:ext cx="10972800" cy="365760"/>
+          </a:xfrm>
+          <a:prstGeom prst="rect">
+            <a:avLst/>
+          </a:prstGeom>
+          <a:noFill/>
+        </p:spPr>
+        <p:txBody>
+          <a:bodyPr wrap="square">
+            <a:spAutoFit/>
+          </a:bodyPr>
+          <a:lstStyle/>
+          <a:p>
+            <a:pPr algn="l"/>
+            <a:r>
+              <a:rPr sz="1400" b="1">
+                <a:solidFill>
+                  <a:srgbClr val="606EF5"/>
+                </a:solidFill>
+              </a:rPr>
+              <a:t>🐛  Fixed: Control Plane &amp; Usage Showing Zero</a:t>
+            </a:r>
+          </a:p>
+        </p:txBody>
+      </p:sp>
+      <p:sp>
+        <p:nvSpPr>
+          <p:cNvPr id="17" name="TextBox 16"/>
+          <p:cNvSpPr txBox="1"/>
+          <p:nvPr/>
+        </p:nvSpPr>
+        <p:spPr>
+          <a:xfrm>
+            <a:off x="594360" y="4608639"/>
+            <a:ext cx="11064240" cy="457200"/>
+          </a:xfrm>
+          <a:prstGeom prst="rect">
+            <a:avLst/>
+          </a:prstGeom>
+          <a:noFill/>
+        </p:spPr>
+        <p:txBody>
+          <a:bodyPr wrap="square">
+            <a:spAutoFit/>
+          </a:bodyPr>
+          <a:lstStyle/>
+          <a:p>
+            <a:pPr algn="l"/>
+            <a:r>
+              <a:rPr sz="1050" b="0">
+                <a:solidFill>
+                  <a:srgbClr val="CBD5E1"/>
+                </a:solidFill>
+              </a:rPr>
+              <a:t>/api/control-plane/stats was silently crashing with a 500 — Postgres returns a float for one average and a Decimal for another, and adding them raised a TypeError. Both dashboards swallowed the error and showed 0/blank stat cards despite real data sitting in the tables directly below them. Cast both averages to float; verified live with real numbers (4 agents, 7 genuine runs).</a:t>
+            </a:r>
+          </a:p>
+        </p:txBody>
+      </p:sp>
+      <p:sp>
+        <p:nvSpPr>
+          <p:cNvPr id="18" name="Rectangle 17"/>
+          <p:cNvSpPr/>
+          <p:nvPr/>
+        </p:nvSpPr>
+        <p:spPr>
+          <a:xfrm>
+            <a:off x="365760" y="5120640"/>
+            <a:ext cx="73152" cy="777240"/>
+          </a:xfrm>
+          <a:prstGeom prst="rect">
+            <a:avLst/>
+          </a:prstGeom>
+          <a:solidFill>
+            <a:srgbClr val="606EF5"/>
+          </a:solidFill>
+          <a:ln>
+            <a:noFill/>
+          </a:ln>
+          <a:effectLst/>
+        </p:spPr>
+        <p:style>
+          <a:lnRef idx="1">
+            <a:schemeClr val="accent1"/>
+          </a:lnRef>
+          <a:fillRef idx="3">
+            <a:schemeClr val="accent1"/>
+          </a:fillRef>
+          <a:effectRef idx="2">
+            <a:schemeClr val="accent1"/>
+          </a:effectRef>
+          <a:fontRef idx="minor">
+            <a:schemeClr val="lt1"/>
+          </a:fontRef>
+        </p:style>
+        <p:txBody>
+          <a:bodyPr rtlCol="0" anchor="ctr"/>
+          <a:lstStyle/>
+          <a:p>
+            <a:pPr algn="ctr"/>
+          </a:p>
+        </p:txBody>
+      </p:sp>
+      <p:sp>
+        <p:nvSpPr>
+          <p:cNvPr id="19" name="TextBox 18"/>
+          <p:cNvSpPr txBox="1"/>
+          <p:nvPr/>
+        </p:nvSpPr>
+        <p:spPr>
+          <a:xfrm>
+            <a:off x="594360" y="5138928"/>
+            <a:ext cx="10972800" cy="365760"/>
+          </a:xfrm>
+          <a:prstGeom prst="rect">
+            <a:avLst/>
+          </a:prstGeom>
+          <a:noFill/>
+        </p:spPr>
+        <p:txBody>
+          <a:bodyPr wrap="square">
+            <a:spAutoFit/>
+          </a:bodyPr>
+          <a:lstStyle/>
+          <a:p>
+            <a:pPr algn="l"/>
+            <a:r>
+              <a:rPr sz="1400" b="1">
+                <a:solidFill>
+                  <a:srgbClr val="606EF5"/>
+                </a:solidFill>
+              </a:rPr>
+              <a:t>🧹  Sidebar Naming Consistency</a:t>
+            </a:r>
+          </a:p>
+        </p:txBody>
+      </p:sp>
+      <p:sp>
+        <p:nvSpPr>
+          <p:cNvPr id="20" name="TextBox 19"/>
+          <p:cNvSpPr txBox="1"/>
+          <p:nvPr/>
+        </p:nvSpPr>
+        <p:spPr>
+          <a:xfrm>
+            <a:off x="594360" y="5504751"/>
+            <a:ext cx="11064240" cy="457200"/>
+          </a:xfrm>
+          <a:prstGeom prst="rect">
+            <a:avLst/>
+          </a:prstGeom>
+          <a:noFill/>
+        </p:spPr>
+        <p:txBody>
+          <a:bodyPr wrap="square">
+            <a:spAutoFit/>
+          </a:bodyPr>
+          <a:lstStyle/>
+          <a:p>
+            <a:pPr algn="l"/>
+            <a:r>
+              <a:rPr sz="1050" b="0">
+                <a:solidFill>
+                  <a:srgbClr val="CBD5E1"/>
+                </a:solidFill>
+              </a:rPr>
+              <a:t>Sidebar labels now match each page's own on-page title exactly instead of drifting from it — closing a three-way mismatch between the nav label, the page's own heading, and the route/filename that made it unclear which page you'd actually land on.</a:t>
+            </a:r>
+          </a:p>
+        </p:txBody>
+      </p:sp>
+      <p:sp>
+        <p:nvSpPr>
+          <p:cNvPr id="21" name="TextBox 20"/>
+          <p:cNvSpPr txBox="1"/>
+          <p:nvPr/>
+        </p:nvSpPr>
+        <p:spPr>
+          <a:xfrm>
+            <a:off x="11640312" y="6492240"/>
             <a:ext cx="457200" cy="320040"/>
           </a:xfrm>
           <a:prstGeom prst="rect">
@@ -38435,129 +39022,19 @@
           <a:noFill/>
         </p:spPr>
         <p:txBody>
-          <a:bodyPr wrap="none">
-            <a:spAutoFit/>
-          </a:bodyPr>
-          <a:lstStyle/>
-          <a:p>
-            <a:r>
-              <a:rPr sz="1100">
+          <a:bodyPr wrap="square">
+            <a:spAutoFit/>
+          </a:bodyPr>
+          <a:lstStyle/>
+          <a:p>
+            <a:pPr algn="l"/>
+            <a:r>
+              <a:rPr sz="1100" b="0">
                 <a:solidFill>
                   <a:srgbClr val="CBD5E1"/>
                 </a:solidFill>
               </a:rPr>
-              <a:t>35</a:t>
-            </a:r>
-          </a:p>
-        </p:txBody>
-      </p:sp>
-      <p:pic>
-        <p:nvPicPr>
-          <p:cNvPr id="6" name="Picture 5" descr="02_builder_templates.png"/>
-          <p:cNvPicPr>
-            <a:picLocks noChangeAspect="1"/>
-          </p:cNvPicPr>
-          <p:nvPr/>
-        </p:nvPicPr>
-        <p:blipFill>
-          <a:blip r:embed="rId2"/>
-          <a:stretch>
-            <a:fillRect/>
-          </a:stretch>
-        </p:blipFill>
-        <p:spPr>
-          <a:xfrm>
-            <a:off x="457200" y="1051560"/>
-            <a:ext cx="5486400" cy="3086100"/>
-          </a:xfrm>
-          <a:prstGeom prst="rect">
-            <a:avLst/>
-          </a:prstGeom>
-          <a:ln w="12700">
-            <a:solidFill>
-              <a:srgbClr val="334155"/>
-            </a:solidFill>
-          </a:ln>
-        </p:spPr>
-      </p:pic>
-      <p:pic>
-        <p:nvPicPr>
-          <p:cNvPr id="7" name="Picture 6" descr="03_builder_autobuild.png"/>
-          <p:cNvPicPr>
-            <a:picLocks noChangeAspect="1"/>
-          </p:cNvPicPr>
-          <p:nvPr/>
-        </p:nvPicPr>
-        <p:blipFill>
-          <a:blip r:embed="rId3"/>
-          <a:stretch>
-            <a:fillRect/>
-          </a:stretch>
-        </p:blipFill>
-        <p:spPr>
-          <a:xfrm>
-            <a:off x="6172200" y="1051560"/>
-            <a:ext cx="5486400" cy="3086100"/>
-          </a:xfrm>
-          <a:prstGeom prst="rect">
-            <a:avLst/>
-          </a:prstGeom>
-          <a:ln w="12700">
-            <a:solidFill>
-              <a:srgbClr val="334155"/>
-            </a:solidFill>
-          </a:ln>
-        </p:spPr>
-      </p:pic>
-      <p:sp>
-        <p:nvSpPr>
-          <p:cNvPr id="8" name="TextBox 7"/>
-          <p:cNvSpPr txBox="1"/>
-          <p:nvPr/>
-        </p:nvSpPr>
-        <p:spPr>
-          <a:xfrm>
-            <a:off x="457200" y="5440680"/>
-            <a:ext cx="11247120" cy="1188720"/>
-          </a:xfrm>
-          <a:prstGeom prst="rect">
-            <a:avLst/>
-          </a:prstGeom>
-          <a:noFill/>
-        </p:spPr>
-        <p:txBody>
-          <a:bodyPr wrap="square">
-            <a:spAutoFit/>
-          </a:bodyPr>
-          <a:lstStyle/>
-          <a:p>
-            <a:pPr>
-              <a:spcAft>
-                <a:spcPts val="400"/>
-              </a:spcAft>
-            </a:pPr>
-            <a:r>
-              <a:rPr sz="1100">
-                <a:solidFill>
-                  <a:srgbClr val="CBD5E1"/>
-                </a:solidFill>
-              </a:rPr>
-              <a:t>① Templates — pick from 40+ ready-made multi-agent pipelines across 10 categories (Architecture, Sales &amp; Marketing, Customer Support, and more) and load one straight onto the canvas.</a:t>
-            </a:r>
-          </a:p>
-          <a:p>
-            <a:pPr>
-              <a:spcAft>
-                <a:spcPts val="400"/>
-              </a:spcAft>
-            </a:pPr>
-            <a:r>
-              <a:rPr sz="1100">
-                <a:solidFill>
-                  <a:srgbClr val="CBD5E1"/>
-                </a:solidFill>
-              </a:rPr>
-              <a:t>② Auto-Build — describe your pipeline in plain English (“A customer support pipeline that classifies queries, routes to the right responder...”) and GPT-5.4-mini generates a 3–6 role-typed node graph automatically.</a:t>
+              <a:t>35a</a:t>
             </a:r>
           </a:p>
         </p:txBody>
@@ -38705,7 +39182,7 @@
                   <a:srgbClr val="FFFFFF"/>
                 </a:solidFill>
               </a:rPr>
-              <a:t>How To Use: Visual Builder — Configure, Export &amp; Import</a:t>
+              <a:t>How To Use: Visual Builder — Templates &amp; Auto-Build</a:t>
             </a:r>
           </a:p>
         </p:txBody>
@@ -38738,14 +39215,14 @@
                   <a:srgbClr val="CBD5E1"/>
                 </a:solidFill>
               </a:rPr>
-              <a:t>36</a:t>
+              <a:t>35</a:t>
             </a:r>
           </a:p>
         </p:txBody>
       </p:sp>
       <p:pic>
         <p:nvPicPr>
-          <p:cNvPr id="6" name="Picture 5" descr="04_builder_agent_config.png"/>
+          <p:cNvPr id="6" name="Picture 5" descr="02_builder_templates.png"/>
           <p:cNvPicPr>
             <a:picLocks noChangeAspect="1"/>
           </p:cNvPicPr>
@@ -38774,7 +39251,7 @@
       </p:pic>
       <p:pic>
         <p:nvPicPr>
-          <p:cNvPr id="7" name="Picture 6" descr="05_builder_export_code.png"/>
+          <p:cNvPr id="7" name="Picture 6" descr="03_builder_autobuild.png"/>
           <p:cNvPicPr>
             <a:picLocks noChangeAspect="1"/>
           </p:cNvPicPr>
@@ -38834,7 +39311,7 @@
                   <a:srgbClr val="CBD5E1"/>
                 </a:solidFill>
               </a:rPr>
-              <a:t>① Configure — click any node to set its Role, System Prompt, Model (Local Model or Azure GPT-5.4-mini, per agent), Tools, and always-on Guardrails, then Save Agent.</a:t>
+              <a:t>① Templates — pick from 40+ ready-made multi-agent pipelines across 10 categories (Architecture, Sales &amp; Marketing, Customer Support, and more) and load one straight onto the canvas.</a:t>
             </a:r>
           </a:p>
           <a:p>
@@ -38849,7 +39326,7 @@
                   <a:srgbClr val="CBD5E1"/>
                 </a:solidFill>
               </a:rPr>
-              <a:t>② Export / Import — Export Code generates a faithful Python script with the same execution logic as the live engine; Export JSON / Import JSON give a lossless, round-trippable workflow backup.</a:t>
+              <a:t>② Auto-Build — describe your pipeline in plain English (“A customer support pipeline that classifies queries, routes to the right responder...”) and GPT-5.4-mini generates a 3–6 role-typed node graph automatically.</a:t>
             </a:r>
           </a:p>
         </p:txBody>
@@ -38997,7 +39474,7 @@
                   <a:srgbClr val="FFFFFF"/>
                 </a:solidFill>
               </a:rPr>
-              <a:t>How To Use: Visual Builder — Run &amp; Deploy</a:t>
+              <a:t>How To Use: Visual Builder — Configure, Export &amp; Import</a:t>
             </a:r>
           </a:p>
         </p:txBody>
@@ -39030,14 +39507,14 @@
                   <a:srgbClr val="CBD5E1"/>
                 </a:solidFill>
               </a:rPr>
-              <a:t>37</a:t>
+              <a:t>36</a:t>
             </a:r>
           </a:p>
         </p:txBody>
       </p:sp>
       <p:pic>
         <p:nvPicPr>
-          <p:cNvPr id="6" name="Picture 5" descr="06_builder_run_dialog.png"/>
+          <p:cNvPr id="6" name="Picture 5" descr="04_builder_agent_config.png"/>
           <p:cNvPicPr>
             <a:picLocks noChangeAspect="1"/>
           </p:cNvPicPr>
@@ -39051,8 +39528,8 @@
         </p:blipFill>
         <p:spPr>
           <a:xfrm>
-            <a:off x="2651760" y="1051560"/>
-            <a:ext cx="6858000" cy="3857625"/>
+            <a:off x="457200" y="1051560"/>
+            <a:ext cx="5486400" cy="3086100"/>
           </a:xfrm>
           <a:prstGeom prst="rect">
             <a:avLst/>
@@ -39064,9 +39541,38 @@
           </a:ln>
         </p:spPr>
       </p:pic>
-      <p:sp>
-        <p:nvSpPr>
-          <p:cNvPr id="7" name="TextBox 6"/>
+      <p:pic>
+        <p:nvPicPr>
+          <p:cNvPr id="7" name="Picture 6" descr="05_builder_export_code.png"/>
+          <p:cNvPicPr>
+            <a:picLocks noChangeAspect="1"/>
+          </p:cNvPicPr>
+          <p:nvPr/>
+        </p:nvPicPr>
+        <p:blipFill>
+          <a:blip r:embed="rId3"/>
+          <a:stretch>
+            <a:fillRect/>
+          </a:stretch>
+        </p:blipFill>
+        <p:spPr>
+          <a:xfrm>
+            <a:off x="6172200" y="1051560"/>
+            <a:ext cx="5486400" cy="3086100"/>
+          </a:xfrm>
+          <a:prstGeom prst="rect">
+            <a:avLst/>
+          </a:prstGeom>
+          <a:ln w="12700">
+            <a:solidFill>
+              <a:srgbClr val="334155"/>
+            </a:solidFill>
+          </a:ln>
+        </p:spPr>
+      </p:pic>
+      <p:sp>
+        <p:nvSpPr>
+          <p:cNvPr id="8" name="TextBox 7"/>
           <p:cNvSpPr txBox="1"/>
           <p:nvPr/>
         </p:nvSpPr>
@@ -39097,7 +39603,7 @@
                   <a:srgbClr val="CBD5E1"/>
                 </a:solidFill>
               </a:rPr>
-              <a:t>① Run — click Run, and an AI-suggested realistic example input is generated automatically; edit it or keep it, then Execute &amp; Save Trace to watch each node pulse green while running and stay green when done.</a:t>
+              <a:t>① Configure — click any node to set its Role, System Prompt, Model (Local Model or Azure GPT-5.4-mini, per agent), Tools, and always-on Guardrails, then Save Agent.</a:t>
             </a:r>
           </a:p>
           <a:p>
@@ -39112,7 +39618,7 @@
                   <a:srgbClr val="CBD5E1"/>
                 </a:solidFill>
               </a:rPr>
-              <a:t>② Deploy — publish the workflow as a live, callable endpoint once you're happy with a run's trace in Workflow Runs / Observability.</a:t>
+              <a:t>② Export / Import — Export Code generates a faithful Python script with the same execution logic as the live engine; Export JSON / Import JSON give a lossless, round-trippable workflow backup.</a:t>
             </a:r>
           </a:p>
         </p:txBody>
@@ -39260,7 +39766,7 @@
                   <a:srgbClr val="FFFFFF"/>
                 </a:solidFill>
               </a:rPr>
-              <a:t>How To Use: Architect, Agent Studio &amp; Playground</a:t>
+              <a:t>How To Use: Visual Builder — Run &amp; Deploy</a:t>
             </a:r>
           </a:p>
         </p:txBody>
@@ -39293,14 +39799,14 @@
                   <a:srgbClr val="CBD5E1"/>
                 </a:solidFill>
               </a:rPr>
-              <a:t>38</a:t>
+              <a:t>37</a:t>
             </a:r>
           </a:p>
         </p:txBody>
       </p:sp>
       <p:pic>
         <p:nvPicPr>
-          <p:cNvPr id="7" name="Picture 6" descr="08_agent_studio.png"/>
+          <p:cNvPr id="6" name="Picture 5" descr="06_builder_run_dialog.png"/>
           <p:cNvPicPr>
             <a:picLocks noChangeAspect="1"/>
           </p:cNvPicPr>
@@ -39314,8 +39820,8 @@
         </p:blipFill>
         <p:spPr>
           <a:xfrm>
-            <a:off x="6172200" y="1051560"/>
-            <a:ext cx="5486400" cy="3086100"/>
+            <a:off x="2651760" y="1051560"/>
+            <a:ext cx="6858000" cy="3857625"/>
           </a:xfrm>
           <a:prstGeom prst="rect">
             <a:avLst/>
@@ -39329,14 +39835,14 @@
       </p:pic>
       <p:sp>
         <p:nvSpPr>
-          <p:cNvPr id="8" name="TextBox 7"/>
+          <p:cNvPr id="7" name="TextBox 6"/>
           <p:cNvSpPr txBox="1"/>
           <p:nvPr/>
         </p:nvSpPr>
         <p:spPr>
           <a:xfrm>
             <a:off x="457200" y="5440680"/>
-            <a:ext cx="11247120" cy="651460"/>
+            <a:ext cx="11247120" cy="1188720"/>
           </a:xfrm>
           <a:prstGeom prst="rect">
             <a:avLst/>
@@ -39355,12 +39861,12 @@
               </a:spcAft>
             </a:pPr>
             <a:r>
-              <a:rPr lang="en-US" sz="1100" dirty="0">
+              <a:rPr sz="1100">
                 <a:solidFill>
                   <a:srgbClr val="CBD5E1"/>
                 </a:solidFill>
               </a:rPr>
-              <a:t>① Home — landing page with quick actions and recent activity; the fastest way back into any agent, project, or workflow you were last working on. </a:t>
+              <a:t>① Run — click Run, and an AI-suggested realistic example input is generated automatically; edit it or keep it, then Execute &amp; Save Trace to watch each node pulse green while running and stay green when done.</a:t>
             </a:r>
           </a:p>
           <a:p>
@@ -39370,51 +39876,16 @@
               </a:spcAft>
             </a:pPr>
             <a:r>
-              <a:rPr sz="1100" dirty="0">
+              <a:rPr sz="1100">
                 <a:solidFill>
                   <a:srgbClr val="CBD5E1"/>
                 </a:solidFill>
               </a:rPr>
-              <a:t>② Agent Studio — every saved agent lives here: Edit, Test, Deploy, Publish, or ask it something directly. Playground gives each agent its own chat with a one-click “Suggest” example-input button.</a:t>
-            </a:r>
-          </a:p>
-        </p:txBody>
-      </p:sp>
-      <p:pic>
-        <p:nvPicPr>
-          <p:cNvPr id="10" name="Picture 9" descr="11_home.png">
-            <a:extLst>
-              <a:ext uri="{FF2B5EF4-FFF2-40B4-BE49-F238E27FC236}">
-                <a16:creationId xmlns:a16="http://schemas.microsoft.com/office/drawing/2014/main" id="{961B9171-039C-BA53-D873-0BDC693AF21D}"/>
-              </a:ext>
-            </a:extLst>
-          </p:cNvPr>
-          <p:cNvPicPr>
-            <a:picLocks noChangeAspect="1"/>
-          </p:cNvPicPr>
-          <p:nvPr/>
-        </p:nvPicPr>
-        <p:blipFill>
-          <a:blip r:embed="rId3"/>
-          <a:stretch>
-            <a:fillRect/>
-          </a:stretch>
-        </p:blipFill>
-        <p:spPr>
-          <a:xfrm>
-            <a:off x="457200" y="1051560"/>
-            <a:ext cx="5486400" cy="3086100"/>
-          </a:xfrm>
-          <a:prstGeom prst="rect">
-            <a:avLst/>
-          </a:prstGeom>
-          <a:ln w="12700">
-            <a:solidFill>
-              <a:srgbClr val="334155"/>
-            </a:solidFill>
-          </a:ln>
-        </p:spPr>
-      </p:pic>
+              <a:t>② Deploy — publish the workflow as a live, callable endpoint once you're happy with a run's trace in Workflow Runs / Observability.</a:t>
+            </a:r>
+          </a:p>
+        </p:txBody>
+      </p:sp>
     </p:spTree>
   </p:cSld>
   <p:clrMapOvr>
@@ -40535,7 +41006,7 @@
                   <a:srgbClr val="FFFFFF"/>
                 </a:solidFill>
               </a:rPr>
-              <a:t>How To Use: Playground — Test Any Agent Live</a:t>
+              <a:t>How To Use: Architect, Agent Studio &amp; Playground</a:t>
             </a:r>
           </a:p>
         </p:txBody>
@@ -40568,67 +41039,14 @@
                   <a:srgbClr val="CBD5E1"/>
                 </a:solidFill>
               </a:rPr>
-              <a:t>39</a:t>
-            </a:r>
-          </a:p>
-        </p:txBody>
-      </p:sp>
-      <p:sp>
-        <p:nvSpPr>
-          <p:cNvPr id="7" name="TextBox 6"/>
-          <p:cNvSpPr txBox="1"/>
-          <p:nvPr/>
-        </p:nvSpPr>
-        <p:spPr>
-          <a:xfrm>
-            <a:off x="457200" y="5440680"/>
-            <a:ext cx="11247120" cy="1188720"/>
-          </a:xfrm>
-          <a:prstGeom prst="rect">
-            <a:avLst/>
-          </a:prstGeom>
-          <a:noFill/>
-        </p:spPr>
-        <p:txBody>
-          <a:bodyPr wrap="square">
-            <a:spAutoFit/>
-          </a:bodyPr>
-          <a:lstStyle/>
-          <a:p>
-            <a:pPr>
-              <a:spcAft>
-                <a:spcPts val="400"/>
-              </a:spcAft>
-            </a:pPr>
-            <a:r>
-              <a:rPr sz="1100">
-                <a:solidFill>
-                  <a:srgbClr val="CBD5E1"/>
-                </a:solidFill>
-              </a:rPr>
-              <a:t>① Open any agent's Playground to see its System Prompt, Guardrails, Tools, and the exact Model it runs on (accurately resolved per agent — Local Model or Azure GPT-5.4-mini, not a stale label).</a:t>
-            </a:r>
-          </a:p>
-          <a:p>
-            <a:pPr>
-              <a:spcAft>
-                <a:spcPts val="400"/>
-              </a:spcAft>
-            </a:pPr>
-            <a:r>
-              <a:rPr sz="1100">
-                <a:solidFill>
-                  <a:srgbClr val="CBD5E1"/>
-                </a:solidFill>
-              </a:rPr>
-              <a:t>② Click Suggest for an AI-generated realistic example message tailored to that agent, or type your own — then Send to test it live and watch Session Stats (Total Runs, Avg ms) update.</a:t>
+              <a:t>38</a:t>
             </a:r>
           </a:p>
         </p:txBody>
       </p:sp>
       <p:pic>
         <p:nvPicPr>
-          <p:cNvPr id="8" name="Picture 7" descr="10_playground_suggest.png"/>
+          <p:cNvPr id="7" name="Picture 6" descr="08_agent_studio.png"/>
           <p:cNvPicPr>
             <a:picLocks noChangeAspect="1"/>
           </p:cNvPicPr>
@@ -40642,8 +41060,96 @@
         </p:blipFill>
         <p:spPr>
           <a:xfrm>
-            <a:off x="2651760" y="1051560"/>
-            <a:ext cx="6858000" cy="3857625"/>
+            <a:off x="6172200" y="1051560"/>
+            <a:ext cx="5486400" cy="3086100"/>
+          </a:xfrm>
+          <a:prstGeom prst="rect">
+            <a:avLst/>
+          </a:prstGeom>
+          <a:ln w="12700">
+            <a:solidFill>
+              <a:srgbClr val="334155"/>
+            </a:solidFill>
+          </a:ln>
+        </p:spPr>
+      </p:pic>
+      <p:sp>
+        <p:nvSpPr>
+          <p:cNvPr id="8" name="TextBox 7"/>
+          <p:cNvSpPr txBox="1"/>
+          <p:nvPr/>
+        </p:nvSpPr>
+        <p:spPr>
+          <a:xfrm>
+            <a:off x="457200" y="5440680"/>
+            <a:ext cx="11247120" cy="651460"/>
+          </a:xfrm>
+          <a:prstGeom prst="rect">
+            <a:avLst/>
+          </a:prstGeom>
+          <a:noFill/>
+        </p:spPr>
+        <p:txBody>
+          <a:bodyPr wrap="square">
+            <a:spAutoFit/>
+          </a:bodyPr>
+          <a:lstStyle/>
+          <a:p>
+            <a:pPr>
+              <a:spcAft>
+                <a:spcPts val="400"/>
+              </a:spcAft>
+            </a:pPr>
+            <a:r>
+              <a:rPr lang="en-US" sz="1100" dirty="0">
+                <a:solidFill>
+                  <a:srgbClr val="CBD5E1"/>
+                </a:solidFill>
+              </a:rPr>
+              <a:t>① Home — landing page with quick actions and recent activity; the fastest way back into any agent, project, or workflow you were last working on. </a:t>
+            </a:r>
+          </a:p>
+          <a:p>
+            <a:pPr>
+              <a:spcAft>
+                <a:spcPts val="400"/>
+              </a:spcAft>
+            </a:pPr>
+            <a:r>
+              <a:rPr sz="1100" dirty="0">
+                <a:solidFill>
+                  <a:srgbClr val="CBD5E1"/>
+                </a:solidFill>
+              </a:rPr>
+              <a:t>② Agent Studio — every saved agent lives here: Edit, Test, Deploy, Publish, or ask it something directly. Playground gives each agent its own chat with a one-click “Suggest” example-input button.</a:t>
+            </a:r>
+          </a:p>
+        </p:txBody>
+      </p:sp>
+      <p:pic>
+        <p:nvPicPr>
+          <p:cNvPr id="10" name="Picture 9" descr="11_home.png">
+            <a:extLst>
+              <a:ext uri="{FF2B5EF4-FFF2-40B4-BE49-F238E27FC236}">
+                <a16:creationId xmlns:a16="http://schemas.microsoft.com/office/drawing/2014/main" id="{961B9171-039C-BA53-D873-0BDC693AF21D}"/>
+              </a:ext>
+            </a:extLst>
+          </p:cNvPr>
+          <p:cNvPicPr>
+            <a:picLocks noChangeAspect="1"/>
+          </p:cNvPicPr>
+          <p:nvPr/>
+        </p:nvPicPr>
+        <p:blipFill>
+          <a:blip r:embed="rId3"/>
+          <a:stretch>
+            <a:fillRect/>
+          </a:stretch>
+        </p:blipFill>
+        <p:spPr>
+          <a:xfrm>
+            <a:off x="457200" y="1051560"/>
+            <a:ext cx="5486400" cy="3086100"/>
           </a:xfrm>
           <a:prstGeom prst="rect">
             <a:avLst/>
@@ -40779,42 +41285,26 @@
         <p:spPr>
           <a:xfrm>
             <a:off x="457200" y="274320"/>
-            <a:ext cx="10972800" cy="492443"/>
-          </a:xfrm>
-          <a:prstGeom prst="rect">
-            <a:avLst/>
-          </a:prstGeom>
-          <a:noFill/>
-        </p:spPr>
-        <p:txBody>
-          <a:bodyPr wrap="square">
-            <a:spAutoFit/>
-          </a:bodyPr>
-          <a:lstStyle/>
-          <a:p>
-            <a:r>
-              <a:rPr sz="2600" b="1" dirty="0">
+            <a:ext cx="10972800" cy="548640"/>
+          </a:xfrm>
+          <a:prstGeom prst="rect">
+            <a:avLst/>
+          </a:prstGeom>
+          <a:noFill/>
+        </p:spPr>
+        <p:txBody>
+          <a:bodyPr wrap="square">
+            <a:spAutoFit/>
+          </a:bodyPr>
+          <a:lstStyle/>
+          <a:p>
+            <a:r>
+              <a:rPr sz="2600" b="1">
                 <a:solidFill>
                   <a:srgbClr val="FFFFFF"/>
                 </a:solidFill>
               </a:rPr>
-              <a:t>How To Use: </a:t>
-            </a:r>
-            <a:r>
-              <a:rPr lang="en-US" sz="2600" b="1" dirty="0">
-                <a:solidFill>
-                  <a:srgbClr val="FFFFFF"/>
-                </a:solidFill>
-              </a:rPr>
-              <a:t>Architect</a:t>
-            </a:r>
-            <a:r>
-              <a:rPr sz="2600" b="1" dirty="0">
-                <a:solidFill>
-                  <a:srgbClr val="FFFFFF"/>
-                </a:solidFill>
-              </a:rPr>
-              <a:t> &amp; Prompt Library</a:t>
+              <a:t>How To Use: Playground — Test Any Agent Live</a:t>
             </a:r>
           </a:p>
         </p:txBody>
@@ -40847,14 +41337,67 @@
                   <a:srgbClr val="CBD5E1"/>
                 </a:solidFill>
               </a:rPr>
-              <a:t>40</a:t>
+              <a:t>39</a:t>
+            </a:r>
+          </a:p>
+        </p:txBody>
+      </p:sp>
+      <p:sp>
+        <p:nvSpPr>
+          <p:cNvPr id="7" name="TextBox 6"/>
+          <p:cNvSpPr txBox="1"/>
+          <p:nvPr/>
+        </p:nvSpPr>
+        <p:spPr>
+          <a:xfrm>
+            <a:off x="457200" y="5440680"/>
+            <a:ext cx="11247120" cy="1188720"/>
+          </a:xfrm>
+          <a:prstGeom prst="rect">
+            <a:avLst/>
+          </a:prstGeom>
+          <a:noFill/>
+        </p:spPr>
+        <p:txBody>
+          <a:bodyPr wrap="square">
+            <a:spAutoFit/>
+          </a:bodyPr>
+          <a:lstStyle/>
+          <a:p>
+            <a:pPr>
+              <a:spcAft>
+                <a:spcPts val="400"/>
+              </a:spcAft>
+            </a:pPr>
+            <a:r>
+              <a:rPr sz="1100">
+                <a:solidFill>
+                  <a:srgbClr val="CBD5E1"/>
+                </a:solidFill>
+              </a:rPr>
+              <a:t>① Open any agent's Playground to see its System Prompt, Guardrails, Tools, and the exact Model it runs on (accurately resolved per agent — Local Model or Azure GPT-5.4-mini, not a stale label).</a:t>
+            </a:r>
+          </a:p>
+          <a:p>
+            <a:pPr>
+              <a:spcAft>
+                <a:spcPts val="400"/>
+              </a:spcAft>
+            </a:pPr>
+            <a:r>
+              <a:rPr sz="1100">
+                <a:solidFill>
+                  <a:srgbClr val="CBD5E1"/>
+                </a:solidFill>
+              </a:rPr>
+              <a:t>② Click Suggest for an AI-generated realistic example message tailored to that agent, or type your own — then Send to test it live and watch Session Stats (Total Runs, Avg ms) update.</a:t>
             </a:r>
           </a:p>
         </p:txBody>
       </p:sp>
       <p:pic>
         <p:nvPicPr>
-          <p:cNvPr id="7" name="Picture 6" descr="12_prompt_library.png"/>
+          <p:cNvPr id="8" name="Picture 7" descr="10_playground_suggest.png"/>
           <p:cNvPicPr>
             <a:picLocks noChangeAspect="1"/>
           </p:cNvPicPr>
@@ -40868,108 +41411,8 @@
         </p:blipFill>
         <p:spPr>
           <a:xfrm>
-            <a:off x="6172200" y="1051560"/>
-            <a:ext cx="5486400" cy="3086100"/>
-          </a:xfrm>
-          <a:prstGeom prst="rect">
-            <a:avLst/>
-          </a:prstGeom>
-          <a:ln w="12700">
-            <a:solidFill>
-              <a:srgbClr val="334155"/>
-            </a:solidFill>
-          </a:ln>
-        </p:spPr>
-      </p:pic>
-      <p:sp>
-        <p:nvSpPr>
-          <p:cNvPr id="8" name="TextBox 7"/>
-          <p:cNvSpPr txBox="1"/>
-          <p:nvPr/>
-        </p:nvSpPr>
-        <p:spPr>
-          <a:xfrm>
-            <a:off x="457200" y="5440680"/>
-            <a:ext cx="11247120" cy="872034"/>
-          </a:xfrm>
-          <a:prstGeom prst="rect">
-            <a:avLst/>
-          </a:prstGeom>
-          <a:noFill/>
-        </p:spPr>
-        <p:txBody>
-          <a:bodyPr wrap="square">
-            <a:spAutoFit/>
-          </a:bodyPr>
-          <a:lstStyle/>
-          <a:p>
-            <a:pPr>
-              <a:spcAft>
-                <a:spcPts val="400"/>
-              </a:spcAft>
-            </a:pPr>
-            <a:r>
-              <a:rPr lang="en-US" sz="1100" dirty="0">
-                <a:solidFill>
-                  <a:srgbClr val="CBD5E1"/>
-                </a:solidFill>
-              </a:rPr>
-              <a:t>① Architect — describe what you want to build in plain English; it asks clarifying questions, then generates a full Plan / Agents / App / Database, downloadable as a RAG Scaffold or Custom Code ZIP.</a:t>
-            </a:r>
-          </a:p>
-          <a:p>
-            <a:pPr>
-              <a:spcAft>
-                <a:spcPts val="400"/>
-              </a:spcAft>
-            </a:pPr>
-            <a:endParaRPr sz="1100" dirty="0">
-              <a:solidFill>
-                <a:srgbClr val="CBD5E1"/>
-              </a:solidFill>
-            </a:endParaRPr>
-          </a:p>
-          <a:p>
-            <a:pPr>
-              <a:spcAft>
-                <a:spcPts val="400"/>
-              </a:spcAft>
-            </a:pPr>
-            <a:r>
-              <a:rPr sz="1100" dirty="0">
-                <a:solidFill>
-                  <a:srgbClr val="CBD5E1"/>
-                </a:solidFill>
-              </a:rPr>
-              <a:t>② Prompt Library — 46+ curated multi-agent prompts across 10 domains (Support, Sales, Legal, HR, Data, and more); search, preview, and copy straight into Architect or Agent Studio.</a:t>
-            </a:r>
-          </a:p>
-        </p:txBody>
-      </p:sp>
-      <p:pic>
-        <p:nvPicPr>
-          <p:cNvPr id="10" name="Picture 9" descr="07_architect.png">
-            <a:extLst>
-              <a:ext uri="{FF2B5EF4-FFF2-40B4-BE49-F238E27FC236}">
-                <a16:creationId xmlns:a16="http://schemas.microsoft.com/office/drawing/2014/main" id="{A6EA2B05-A44A-923C-6A12-9B1083B342D1}"/>
-              </a:ext>
-            </a:extLst>
-          </p:cNvPr>
-          <p:cNvPicPr>
-            <a:picLocks noChangeAspect="1"/>
-          </p:cNvPicPr>
-          <p:nvPr/>
-        </p:nvPicPr>
-        <p:blipFill>
-          <a:blip r:embed="rId3"/>
-          <a:stretch>
-            <a:fillRect/>
-          </a:stretch>
-        </p:blipFill>
-        <p:spPr>
-          <a:xfrm>
-            <a:off x="457200" y="1051560"/>
-            <a:ext cx="5486400" cy="3086100"/>
+            <a:off x="2651760" y="1051560"/>
+            <a:ext cx="6858000" cy="3857625"/>
           </a:xfrm>
           <a:prstGeom prst="rect">
             <a:avLst/>
@@ -41105,26 +41548,42 @@
         <p:spPr>
           <a:xfrm>
             <a:off x="457200" y="274320"/>
-            <a:ext cx="10972800" cy="548640"/>
-          </a:xfrm>
-          <a:prstGeom prst="rect">
-            <a:avLst/>
-          </a:prstGeom>
-          <a:noFill/>
-        </p:spPr>
-        <p:txBody>
-          <a:bodyPr wrap="square">
-            <a:spAutoFit/>
-          </a:bodyPr>
-          <a:lstStyle/>
-          <a:p>
-            <a:r>
-              <a:rPr sz="2600" b="1">
+            <a:ext cx="10972800" cy="492443"/>
+          </a:xfrm>
+          <a:prstGeom prst="rect">
+            <a:avLst/>
+          </a:prstGeom>
+          <a:noFill/>
+        </p:spPr>
+        <p:txBody>
+          <a:bodyPr wrap="square">
+            <a:spAutoFit/>
+          </a:bodyPr>
+          <a:lstStyle/>
+          <a:p>
+            <a:r>
+              <a:rPr sz="2600" b="1" dirty="0">
                 <a:solidFill>
                   <a:srgbClr val="FFFFFF"/>
                 </a:solidFill>
               </a:rPr>
-              <a:t>How To Use: Control Plane &amp; Audit Traceability</a:t>
+              <a:t>How To Use: </a:t>
+            </a:r>
+            <a:r>
+              <a:rPr lang="en-US" sz="2600" b="1" dirty="0">
+                <a:solidFill>
+                  <a:srgbClr val="FFFFFF"/>
+                </a:solidFill>
+              </a:rPr>
+              <a:t>Architect</a:t>
+            </a:r>
+            <a:r>
+              <a:rPr sz="2600" b="1" dirty="0">
+                <a:solidFill>
+                  <a:srgbClr val="FFFFFF"/>
+                </a:solidFill>
+              </a:rPr>
+              <a:t> &amp; Prompt Library</a:t>
             </a:r>
           </a:p>
         </p:txBody>
@@ -41157,14 +41616,14 @@
                   <a:srgbClr val="CBD5E1"/>
                 </a:solidFill>
               </a:rPr>
-              <a:t>41</a:t>
+              <a:t>40</a:t>
             </a:r>
           </a:p>
         </p:txBody>
       </p:sp>
       <p:pic>
         <p:nvPicPr>
-          <p:cNvPr id="6" name="Picture 5" descr="13_control_plane.png"/>
+          <p:cNvPr id="7" name="Picture 6" descr="12_prompt_library.png"/>
           <p:cNvPicPr>
             <a:picLocks noChangeAspect="1"/>
           </p:cNvPicPr>
@@ -41178,7 +41637,7 @@
         </p:blipFill>
         <p:spPr>
           <a:xfrm>
-            <a:off x="457200" y="1051560"/>
+            <a:off x="6172200" y="1051560"/>
             <a:ext cx="5486400" cy="3086100"/>
           </a:xfrm>
           <a:prstGeom prst="rect">
@@ -41191,9 +41650,80 @@
           </a:ln>
         </p:spPr>
       </p:pic>
+      <p:sp>
+        <p:nvSpPr>
+          <p:cNvPr id="8" name="TextBox 7"/>
+          <p:cNvSpPr txBox="1"/>
+          <p:nvPr/>
+        </p:nvSpPr>
+        <p:spPr>
+          <a:xfrm>
+            <a:off x="457200" y="5440680"/>
+            <a:ext cx="11247120" cy="872034"/>
+          </a:xfrm>
+          <a:prstGeom prst="rect">
+            <a:avLst/>
+          </a:prstGeom>
+          <a:noFill/>
+        </p:spPr>
+        <p:txBody>
+          <a:bodyPr wrap="square">
+            <a:spAutoFit/>
+          </a:bodyPr>
+          <a:lstStyle/>
+          <a:p>
+            <a:pPr>
+              <a:spcAft>
+                <a:spcPts val="400"/>
+              </a:spcAft>
+            </a:pPr>
+            <a:r>
+              <a:rPr lang="en-US" sz="1100" dirty="0">
+                <a:solidFill>
+                  <a:srgbClr val="CBD5E1"/>
+                </a:solidFill>
+              </a:rPr>
+              <a:t>① Architect — describe what you want to build in plain English; it asks clarifying questions, then generates a full Plan / Agents / App / Database, downloadable as a RAG Scaffold or Custom Code ZIP.</a:t>
+            </a:r>
+          </a:p>
+          <a:p>
+            <a:pPr>
+              <a:spcAft>
+                <a:spcPts val="400"/>
+              </a:spcAft>
+            </a:pPr>
+            <a:endParaRPr sz="1100" dirty="0">
+              <a:solidFill>
+                <a:srgbClr val="CBD5E1"/>
+              </a:solidFill>
+            </a:endParaRPr>
+          </a:p>
+          <a:p>
+            <a:pPr>
+              <a:spcAft>
+                <a:spcPts val="400"/>
+              </a:spcAft>
+            </a:pPr>
+            <a:r>
+              <a:rPr sz="1100" dirty="0">
+                <a:solidFill>
+                  <a:srgbClr val="CBD5E1"/>
+                </a:solidFill>
+              </a:rPr>
+              <a:t>② Prompt Library — 46+ curated multi-agent prompts across 10 domains (Support, Sales, Legal, HR, Data, and more); search, preview, and copy straight into Architect or Agent Studio.</a:t>
+            </a:r>
+          </a:p>
+        </p:txBody>
+      </p:sp>
       <p:pic>
         <p:nvPicPr>
-          <p:cNvPr id="7" name="Picture 6" descr="14_usage_audit.png"/>
+          <p:cNvPr id="10" name="Picture 9" descr="07_architect.png">
+            <a:extLst>
+              <a:ext uri="{FF2B5EF4-FFF2-40B4-BE49-F238E27FC236}">
+                <a16:creationId xmlns:a16="http://schemas.microsoft.com/office/drawing/2014/main" id="{A6EA2B05-A44A-923C-6A12-9B1083B342D1}"/>
+              </a:ext>
+            </a:extLst>
+          </p:cNvPr>
           <p:cNvPicPr>
             <a:picLocks noChangeAspect="1"/>
           </p:cNvPicPr>
@@ -41207,7 +41737,7 @@
         </p:blipFill>
         <p:spPr>
           <a:xfrm>
-            <a:off x="6172200" y="1051560"/>
+            <a:off x="457200" y="1051560"/>
             <a:ext cx="5486400" cy="3086100"/>
           </a:xfrm>
           <a:prstGeom prst="rect">
@@ -41220,59 +41750,6 @@
           </a:ln>
         </p:spPr>
       </p:pic>
-      <p:sp>
-        <p:nvSpPr>
-          <p:cNvPr id="8" name="TextBox 7"/>
-          <p:cNvSpPr txBox="1"/>
-          <p:nvPr/>
-        </p:nvSpPr>
-        <p:spPr>
-          <a:xfrm>
-            <a:off x="457200" y="5440680"/>
-            <a:ext cx="11247120" cy="1188720"/>
-          </a:xfrm>
-          <a:prstGeom prst="rect">
-            <a:avLst/>
-          </a:prstGeom>
-          <a:noFill/>
-        </p:spPr>
-        <p:txBody>
-          <a:bodyPr wrap="square">
-            <a:spAutoFit/>
-          </a:bodyPr>
-          <a:lstStyle/>
-          <a:p>
-            <a:pPr>
-              <a:spcAft>
-                <a:spcPts val="400"/>
-              </a:spcAft>
-            </a:pPr>
-            <a:r>
-              <a:rPr sz="1100">
-                <a:solidFill>
-                  <a:srgbClr val="CBD5E1"/>
-                </a:solidFill>
-              </a:rPr>
-              <a:t>① Control Plane — live platform health: active agents, runs, guardrail triggers, and average latency in one dashboard, refreshed in real time.</a:t>
-            </a:r>
-          </a:p>
-          <a:p>
-            <a:pPr>
-              <a:spcAft>
-                <a:spcPts val="400"/>
-              </a:spcAft>
-            </a:pPr>
-            <a:r>
-              <a:rPr sz="1100">
-                <a:solidFill>
-                  <a:srgbClr val="CBD5E1"/>
-                </a:solidFill>
-              </a:rPr>
-              <a:t>② Usage &amp; Traceability — full audit-log viewer: every agent action with user, resource, input/output snapshot, guardrail trigger, latency, and trace ID, filterable by action/agent/date.</a:t>
-            </a:r>
-          </a:p>
-        </p:txBody>
-      </p:sp>
     </p:spTree>
   </p:cSld>
   <p:clrMapOvr>
@@ -41416,7 +41893,7 @@
                   <a:srgbClr val="FFFFFF"/>
                 </a:solidFill>
               </a:rPr>
-              <a:t>How To Use: Workflow Observability — Tracing &amp; Logs</a:t>
+              <a:t>How To Use: Control Plane &amp; Audit Traceability</a:t>
             </a:r>
           </a:p>
         </p:txBody>
@@ -41449,14 +41926,14 @@
                   <a:srgbClr val="CBD5E1"/>
                 </a:solidFill>
               </a:rPr>
-              <a:t>42</a:t>
+              <a:t>41</a:t>
             </a:r>
           </a:p>
         </p:txBody>
       </p:sp>
       <p:pic>
         <p:nvPicPr>
-          <p:cNvPr id="6" name="Picture 5" descr="15_workflow_observability.png"/>
+          <p:cNvPr id="6" name="Picture 5" descr="13_control_plane.png"/>
           <p:cNvPicPr>
             <a:picLocks noChangeAspect="1"/>
           </p:cNvPicPr>
@@ -41470,8 +41947,8 @@
         </p:blipFill>
         <p:spPr>
           <a:xfrm>
-            <a:off x="1737360" y="1051560"/>
-            <a:ext cx="8686800" cy="4886325"/>
+            <a:off x="457200" y="1051560"/>
+            <a:ext cx="5486400" cy="3086100"/>
           </a:xfrm>
           <a:prstGeom prst="rect">
             <a:avLst/>
@@ -41483,16 +41960,45 @@
           </a:ln>
         </p:spPr>
       </p:pic>
-      <p:sp>
-        <p:nvSpPr>
-          <p:cNvPr id="7" name="TextBox 6"/>
-          <p:cNvSpPr txBox="1"/>
-          <p:nvPr/>
-        </p:nvSpPr>
-        <p:spPr>
-          <a:xfrm>
-            <a:off x="457200" y="6157341"/>
-            <a:ext cx="11247120" cy="482183"/>
+      <p:pic>
+        <p:nvPicPr>
+          <p:cNvPr id="7" name="Picture 6" descr="14_usage_audit.png"/>
+          <p:cNvPicPr>
+            <a:picLocks noChangeAspect="1"/>
+          </p:cNvPicPr>
+          <p:nvPr/>
+        </p:nvPicPr>
+        <p:blipFill>
+          <a:blip r:embed="rId3"/>
+          <a:stretch>
+            <a:fillRect/>
+          </a:stretch>
+        </p:blipFill>
+        <p:spPr>
+          <a:xfrm>
+            <a:off x="6172200" y="1051560"/>
+            <a:ext cx="5486400" cy="3086100"/>
+          </a:xfrm>
+          <a:prstGeom prst="rect">
+            <a:avLst/>
+          </a:prstGeom>
+          <a:ln w="12700">
+            <a:solidFill>
+              <a:srgbClr val="334155"/>
+            </a:solidFill>
+          </a:ln>
+        </p:spPr>
+      </p:pic>
+      <p:sp>
+        <p:nvSpPr>
+          <p:cNvPr id="8" name="TextBox 7"/>
+          <p:cNvSpPr txBox="1"/>
+          <p:nvPr/>
+        </p:nvSpPr>
+        <p:spPr>
+          <a:xfrm>
+            <a:off x="457200" y="5440680"/>
+            <a:ext cx="11247120" cy="1188720"/>
           </a:xfrm>
           <a:prstGeom prst="rect">
             <a:avLst/>
@@ -41511,12 +42017,12 @@
               </a:spcAft>
             </a:pPr>
             <a:r>
-              <a:rPr sz="1100" dirty="0">
+              <a:rPr sz="1100">
                 <a:solidFill>
                   <a:srgbClr val="CBD5E1"/>
                 </a:solidFill>
               </a:rPr>
-              <a:t>① Every workflow run is logged here with per-node execution trace, total duration, and final status — including an “Awaiting Approval” count with a direct “Review →” link for paused runs.</a:t>
+              <a:t>① Control Plane — live platform health: active agents, runs, guardrail triggers, and average latency in one dashboard, refreshed in real time.</a:t>
             </a:r>
           </a:p>
           <a:p>
@@ -41526,12 +42032,12 @@
               </a:spcAft>
             </a:pPr>
             <a:r>
-              <a:rPr sz="1100" dirty="0">
+              <a:rPr sz="1100">
                 <a:solidFill>
                   <a:srgbClr val="CBD5E1"/>
                 </a:solidFill>
               </a:rPr>
-              <a:t>② Backed by real Open Telemetry spans on every LLM call, so a slow or failed run can be traced back to the exact node, prompt, and latency that caused it — not a black box.</a:t>
+              <a:t>② Usage &amp; Traceability — full audit-log viewer: every agent action with user, resource, input/output snapshot, guardrail trigger, latency, and trace ID, filterable by action/agent/date.</a:t>
             </a:r>
           </a:p>
         </p:txBody>
@@ -41570,7 +42076,7 @@
         <p:spPr>
           <a:xfrm>
             <a:off x="0" y="0"/>
-            <a:ext cx="12188952" cy="6858000"/>
+            <a:ext cx="12188825" cy="6858000"/>
           </a:xfrm>
           <a:prstGeom prst="rect">
             <a:avLst/>
@@ -41581,6 +42087,7 @@
           <a:ln>
             <a:noFill/>
           </a:ln>
+          <a:effectLst/>
         </p:spPr>
         <p:style>
           <a:lnRef idx="1">
@@ -41613,8 +42120,8 @@
         </p:nvSpPr>
         <p:spPr>
           <a:xfrm>
-            <a:off x="0" y="0"/>
-            <a:ext cx="12188952" cy="45720"/>
+            <a:off x="0" y="73152"/>
+            <a:ext cx="12188825" cy="45720"/>
           </a:xfrm>
           <a:prstGeom prst="rect">
             <a:avLst/>
@@ -41625,6 +42132,7 @@
           <a:ln>
             <a:noFill/>
           </a:ln>
+          <a:effectLst/>
         </p:spPr>
         <p:style>
           <a:lnRef idx="1">
@@ -41651,516 +42159,148 @@
       </p:sp>
       <p:sp>
         <p:nvSpPr>
-          <p:cNvPr id="4" name="Rectangle 3"/>
-          <p:cNvSpPr/>
-          <p:nvPr/>
-        </p:nvSpPr>
-        <p:spPr>
-          <a:xfrm>
-            <a:off x="0" y="1371600"/>
-            <a:ext cx="12188952" cy="4114800"/>
-          </a:xfrm>
-          <a:prstGeom prst="rect">
-            <a:avLst/>
-          </a:prstGeom>
-          <a:solidFill>
-            <a:srgbClr val="1A243E"/>
-          </a:solidFill>
-          <a:ln>
-            <a:noFill/>
+          <p:cNvPr id="4" name="TextBox 3"/>
+          <p:cNvSpPr txBox="1"/>
+          <p:nvPr/>
+        </p:nvSpPr>
+        <p:spPr>
+          <a:xfrm>
+            <a:off x="457200" y="274320"/>
+            <a:ext cx="10972800" cy="548640"/>
+          </a:xfrm>
+          <a:prstGeom prst="rect">
+            <a:avLst/>
+          </a:prstGeom>
+          <a:noFill/>
+        </p:spPr>
+        <p:txBody>
+          <a:bodyPr wrap="square">
+            <a:spAutoFit/>
+          </a:bodyPr>
+          <a:lstStyle/>
+          <a:p>
+            <a:r>
+              <a:rPr sz="2600" b="1">
+                <a:solidFill>
+                  <a:srgbClr val="FFFFFF"/>
+                </a:solidFill>
+              </a:rPr>
+              <a:t>How To Use: Workflow Observability — Tracing &amp; Logs</a:t>
+            </a:r>
+          </a:p>
+        </p:txBody>
+      </p:sp>
+      <p:sp>
+        <p:nvSpPr>
+          <p:cNvPr id="5" name="TextBox 4"/>
+          <p:cNvSpPr txBox="1"/>
+          <p:nvPr/>
+        </p:nvSpPr>
+        <p:spPr>
+          <a:xfrm>
+            <a:off x="11731752" y="6492240"/>
+            <a:ext cx="457200" cy="320040"/>
+          </a:xfrm>
+          <a:prstGeom prst="rect">
+            <a:avLst/>
+          </a:prstGeom>
+          <a:noFill/>
+        </p:spPr>
+        <p:txBody>
+          <a:bodyPr wrap="none">
+            <a:spAutoFit/>
+          </a:bodyPr>
+          <a:lstStyle/>
+          <a:p>
+            <a:r>
+              <a:rPr sz="1100">
+                <a:solidFill>
+                  <a:srgbClr val="CBD5E1"/>
+                </a:solidFill>
+              </a:rPr>
+              <a:t>42</a:t>
+            </a:r>
+          </a:p>
+        </p:txBody>
+      </p:sp>
+      <p:pic>
+        <p:nvPicPr>
+          <p:cNvPr id="6" name="Picture 5" descr="15_workflow_observability.png"/>
+          <p:cNvPicPr>
+            <a:picLocks noChangeAspect="1"/>
+          </p:cNvPicPr>
+          <p:nvPr/>
+        </p:nvPicPr>
+        <p:blipFill>
+          <a:blip r:embed="rId2"/>
+          <a:stretch>
+            <a:fillRect/>
+          </a:stretch>
+        </p:blipFill>
+        <p:spPr>
+          <a:xfrm>
+            <a:off x="1737360" y="1051560"/>
+            <a:ext cx="8686800" cy="4886325"/>
+          </a:xfrm>
+          <a:prstGeom prst="rect">
+            <a:avLst/>
+          </a:prstGeom>
+          <a:ln w="12700">
+            <a:solidFill>
+              <a:srgbClr val="334155"/>
+            </a:solidFill>
           </a:ln>
         </p:spPr>
-        <p:style>
-          <a:lnRef idx="1">
-            <a:schemeClr val="accent1"/>
-          </a:lnRef>
-          <a:fillRef idx="3">
-            <a:schemeClr val="accent1"/>
-          </a:fillRef>
-          <a:effectRef idx="2">
-            <a:schemeClr val="accent1"/>
-          </a:effectRef>
-          <a:fontRef idx="minor">
-            <a:schemeClr val="lt1"/>
-          </a:fontRef>
-        </p:style>
-        <p:txBody>
-          <a:bodyPr rtlCol="0" anchor="ctr"/>
-          <a:lstStyle/>
-          <a:p>
-            <a:pPr algn="ctr"/>
-            <a:endParaRPr/>
-          </a:p>
-        </p:txBody>
-      </p:sp>
-      <p:sp>
-        <p:nvSpPr>
-          <p:cNvPr id="5" name="TextBox 4"/>
-          <p:cNvSpPr txBox="1"/>
-          <p:nvPr/>
-        </p:nvSpPr>
-        <p:spPr>
-          <a:xfrm>
-            <a:off x="457200" y="1645920"/>
-            <a:ext cx="10972800" cy="914400"/>
-          </a:xfrm>
-          <a:prstGeom prst="rect">
-            <a:avLst/>
-          </a:prstGeom>
-          <a:noFill/>
-        </p:spPr>
-        <p:txBody>
-          <a:bodyPr wrap="square">
-            <a:spAutoFit/>
-          </a:bodyPr>
-          <a:lstStyle/>
-          <a:p>
-            <a:pPr algn="ctr"/>
-            <a:r>
-              <a:rPr sz="5400" b="1">
-                <a:solidFill>
-                  <a:srgbClr val="FFFFFF"/>
-                </a:solidFill>
-              </a:rPr>
-              <a:t>AgentForge</a:t>
-            </a:r>
-          </a:p>
-        </p:txBody>
-      </p:sp>
-      <p:sp>
-        <p:nvSpPr>
-          <p:cNvPr id="6" name="TextBox 5"/>
-          <p:cNvSpPr txBox="1"/>
-          <p:nvPr/>
-        </p:nvSpPr>
-        <p:spPr>
-          <a:xfrm>
-            <a:off x="457200" y="2606040"/>
-            <a:ext cx="10972800" cy="731520"/>
-          </a:xfrm>
-          <a:prstGeom prst="rect">
-            <a:avLst/>
-          </a:prstGeom>
-          <a:noFill/>
-        </p:spPr>
-        <p:txBody>
-          <a:bodyPr wrap="square">
-            <a:spAutoFit/>
-          </a:bodyPr>
-          <a:lstStyle/>
-          <a:p>
-            <a:pPr algn="ctr"/>
-            <a:r>
-              <a:rPr sz="2200" b="0">
+      </p:pic>
+      <p:sp>
+        <p:nvSpPr>
+          <p:cNvPr id="7" name="TextBox 6"/>
+          <p:cNvSpPr txBox="1"/>
+          <p:nvPr/>
+        </p:nvSpPr>
+        <p:spPr>
+          <a:xfrm>
+            <a:off x="457200" y="6157341"/>
+            <a:ext cx="11247120" cy="482183"/>
+          </a:xfrm>
+          <a:prstGeom prst="rect">
+            <a:avLst/>
+          </a:prstGeom>
+          <a:noFill/>
+        </p:spPr>
+        <p:txBody>
+          <a:bodyPr wrap="square">
+            <a:spAutoFit/>
+          </a:bodyPr>
+          <a:lstStyle/>
+          <a:p>
+            <a:pPr>
+              <a:spcAft>
+                <a:spcPts val="400"/>
+              </a:spcAft>
+            </a:pPr>
+            <a:r>
+              <a:rPr sz="1100" dirty="0">
                 <a:solidFill>
                   <a:srgbClr val="CBD5E1"/>
                 </a:solidFill>
               </a:rPr>
-              <a:t>Build the next generation of enterprise AI agents — today.</a:t>
-            </a:r>
-          </a:p>
-        </p:txBody>
-      </p:sp>
-      <p:sp>
-        <p:nvSpPr>
-          <p:cNvPr id="7" name="Rectangle 6"/>
-          <p:cNvSpPr/>
-          <p:nvPr/>
-        </p:nvSpPr>
-        <p:spPr>
-          <a:xfrm>
-            <a:off x="1371600" y="3657600"/>
-            <a:ext cx="2834640" cy="777240"/>
-          </a:xfrm>
-          <a:prstGeom prst="rect">
-            <a:avLst/>
-          </a:prstGeom>
-          <a:solidFill>
-            <a:srgbClr val="606EF5"/>
-          </a:solidFill>
-          <a:ln>
-            <a:noFill/>
-          </a:ln>
-        </p:spPr>
-        <p:style>
-          <a:lnRef idx="1">
-            <a:schemeClr val="accent1"/>
-          </a:lnRef>
-          <a:fillRef idx="3">
-            <a:schemeClr val="accent1"/>
-          </a:fillRef>
-          <a:effectRef idx="2">
-            <a:schemeClr val="accent1"/>
-          </a:effectRef>
-          <a:fontRef idx="minor">
-            <a:schemeClr val="lt1"/>
-          </a:fontRef>
-        </p:style>
-        <p:txBody>
-          <a:bodyPr rtlCol="0" anchor="ctr"/>
-          <a:lstStyle/>
-          <a:p>
-            <a:pPr algn="ctr"/>
-            <a:endParaRPr/>
-          </a:p>
-        </p:txBody>
-      </p:sp>
-      <p:sp>
-        <p:nvSpPr>
-          <p:cNvPr id="8" name="TextBox 7"/>
-          <p:cNvSpPr txBox="1"/>
-          <p:nvPr/>
-        </p:nvSpPr>
-        <p:spPr>
-          <a:xfrm>
-            <a:off x="1371600" y="3703320"/>
-            <a:ext cx="2834640" cy="384048"/>
-          </a:xfrm>
-          <a:prstGeom prst="rect">
-            <a:avLst/>
-          </a:prstGeom>
-          <a:noFill/>
-        </p:spPr>
-        <p:txBody>
-          <a:bodyPr wrap="square">
-            <a:spAutoFit/>
-          </a:bodyPr>
-          <a:lstStyle/>
-          <a:p>
-            <a:pPr algn="ctr"/>
-            <a:r>
-              <a:rPr sz="1400" b="1">
-                <a:solidFill>
-                  <a:srgbClr val="FFFFFF"/>
-                </a:solidFill>
-              </a:rPr>
-              <a:t>🚀  Start Building</a:t>
-            </a:r>
-          </a:p>
-        </p:txBody>
-      </p:sp>
-      <p:sp>
-        <p:nvSpPr>
-          <p:cNvPr id="9" name="TextBox 8"/>
-          <p:cNvSpPr txBox="1"/>
-          <p:nvPr/>
-        </p:nvSpPr>
-        <p:spPr>
-          <a:xfrm>
-            <a:off x="1371600" y="4087368"/>
-            <a:ext cx="2834640" cy="320040"/>
-          </a:xfrm>
-          <a:prstGeom prst="rect">
-            <a:avLst/>
-          </a:prstGeom>
-          <a:noFill/>
-        </p:spPr>
-        <p:txBody>
-          <a:bodyPr wrap="square">
-            <a:spAutoFit/>
-          </a:bodyPr>
-          <a:lstStyle/>
-          <a:p>
-            <a:pPr algn="ctr"/>
-            <a:r>
-              <a:rPr sz="1100" b="0">
-                <a:solidFill>
-                  <a:srgbClr val="FFFFFF"/>
-                </a:solidFill>
-              </a:rPr>
-              <a:t>localhost:5173/architect</a:t>
-            </a:r>
-          </a:p>
-        </p:txBody>
-      </p:sp>
-      <p:sp>
-        <p:nvSpPr>
-          <p:cNvPr id="10" name="Rectangle 9"/>
-          <p:cNvSpPr/>
-          <p:nvPr/>
-        </p:nvSpPr>
-        <p:spPr>
-          <a:xfrm>
-            <a:off x="4572000" y="3657600"/>
-            <a:ext cx="2834640" cy="777240"/>
-          </a:xfrm>
-          <a:prstGeom prst="rect">
-            <a:avLst/>
-          </a:prstGeom>
-          <a:solidFill>
-            <a:srgbClr val="10B981"/>
-          </a:solidFill>
-          <a:ln>
-            <a:noFill/>
-          </a:ln>
-        </p:spPr>
-        <p:style>
-          <a:lnRef idx="1">
-            <a:schemeClr val="accent1"/>
-          </a:lnRef>
-          <a:fillRef idx="3">
-            <a:schemeClr val="accent1"/>
-          </a:fillRef>
-          <a:effectRef idx="2">
-            <a:schemeClr val="accent1"/>
-          </a:effectRef>
-          <a:fontRef idx="minor">
-            <a:schemeClr val="lt1"/>
-          </a:fontRef>
-        </p:style>
-        <p:txBody>
-          <a:bodyPr rtlCol="0" anchor="ctr"/>
-          <a:lstStyle/>
-          <a:p>
-            <a:pPr algn="ctr"/>
-            <a:endParaRPr/>
-          </a:p>
-        </p:txBody>
-      </p:sp>
-      <p:sp>
-        <p:nvSpPr>
-          <p:cNvPr id="11" name="TextBox 10"/>
-          <p:cNvSpPr txBox="1"/>
-          <p:nvPr/>
-        </p:nvSpPr>
-        <p:spPr>
-          <a:xfrm>
-            <a:off x="4572000" y="3703320"/>
-            <a:ext cx="2834640" cy="384048"/>
-          </a:xfrm>
-          <a:prstGeom prst="rect">
-            <a:avLst/>
-          </a:prstGeom>
-          <a:noFill/>
-        </p:spPr>
-        <p:txBody>
-          <a:bodyPr wrap="square">
-            <a:spAutoFit/>
-          </a:bodyPr>
-          <a:lstStyle/>
-          <a:p>
-            <a:pPr algn="ctr"/>
-            <a:r>
-              <a:rPr sz="1400" b="1">
-                <a:solidFill>
-                  <a:srgbClr val="FFFFFF"/>
-                </a:solidFill>
-              </a:rPr>
-              <a:t>📖  API Docs</a:t>
-            </a:r>
-          </a:p>
-        </p:txBody>
-      </p:sp>
-      <p:sp>
-        <p:nvSpPr>
-          <p:cNvPr id="12" name="TextBox 11"/>
-          <p:cNvSpPr txBox="1"/>
-          <p:nvPr/>
-        </p:nvSpPr>
-        <p:spPr>
-          <a:xfrm>
-            <a:off x="4572000" y="4087368"/>
-            <a:ext cx="2834640" cy="320040"/>
-          </a:xfrm>
-          <a:prstGeom prst="rect">
-            <a:avLst/>
-          </a:prstGeom>
-          <a:noFill/>
-        </p:spPr>
-        <p:txBody>
-          <a:bodyPr wrap="square">
-            <a:spAutoFit/>
-          </a:bodyPr>
-          <a:lstStyle/>
-          <a:p>
-            <a:pPr algn="ctr"/>
-            <a:r>
-              <a:rPr sz="1100" b="0">
-                <a:solidFill>
-                  <a:srgbClr val="FFFFFF"/>
-                </a:solidFill>
-              </a:rPr>
-              <a:t>localhost:8000/docs</a:t>
-            </a:r>
-          </a:p>
-        </p:txBody>
-      </p:sp>
-      <p:sp>
-        <p:nvSpPr>
-          <p:cNvPr id="13" name="Rectangle 12"/>
-          <p:cNvSpPr/>
-          <p:nvPr/>
-        </p:nvSpPr>
-        <p:spPr>
-          <a:xfrm>
-            <a:off x="7772400" y="3657600"/>
-            <a:ext cx="2834640" cy="777240"/>
-          </a:xfrm>
-          <a:prstGeom prst="rect">
-            <a:avLst/>
-          </a:prstGeom>
-          <a:solidFill>
-            <a:srgbClr val="F59E0B"/>
-          </a:solidFill>
-          <a:ln>
-            <a:noFill/>
-          </a:ln>
-        </p:spPr>
-        <p:style>
-          <a:lnRef idx="1">
-            <a:schemeClr val="accent1"/>
-          </a:lnRef>
-          <a:fillRef idx="3">
-            <a:schemeClr val="accent1"/>
-          </a:fillRef>
-          <a:effectRef idx="2">
-            <a:schemeClr val="accent1"/>
-          </a:effectRef>
-          <a:fontRef idx="minor">
-            <a:schemeClr val="lt1"/>
-          </a:fontRef>
-        </p:style>
-        <p:txBody>
-          <a:bodyPr rtlCol="0" anchor="ctr"/>
-          <a:lstStyle/>
-          <a:p>
-            <a:pPr algn="ctr"/>
-            <a:endParaRPr/>
-          </a:p>
-        </p:txBody>
-      </p:sp>
-      <p:sp>
-        <p:nvSpPr>
-          <p:cNvPr id="14" name="TextBox 13"/>
-          <p:cNvSpPr txBox="1"/>
-          <p:nvPr/>
-        </p:nvSpPr>
-        <p:spPr>
-          <a:xfrm>
-            <a:off x="7772400" y="3703320"/>
-            <a:ext cx="2834640" cy="384048"/>
-          </a:xfrm>
-          <a:prstGeom prst="rect">
-            <a:avLst/>
-          </a:prstGeom>
-          <a:noFill/>
-        </p:spPr>
-        <p:txBody>
-          <a:bodyPr wrap="square">
-            <a:spAutoFit/>
-          </a:bodyPr>
-          <a:lstStyle/>
-          <a:p>
-            <a:pPr algn="ctr"/>
-            <a:r>
-              <a:rPr sz="1400" b="1">
-                <a:solidFill>
-                  <a:srgbClr val="FFFFFF"/>
-                </a:solidFill>
-              </a:rPr>
-              <a:t>📦  Download ZIP</a:t>
-            </a:r>
-          </a:p>
-        </p:txBody>
-      </p:sp>
-      <p:sp>
-        <p:nvSpPr>
-          <p:cNvPr id="15" name="TextBox 14"/>
-          <p:cNvSpPr txBox="1"/>
-          <p:nvPr/>
-        </p:nvSpPr>
-        <p:spPr>
-          <a:xfrm>
-            <a:off x="7772400" y="4087368"/>
-            <a:ext cx="2834640" cy="320040"/>
-          </a:xfrm>
-          <a:prstGeom prst="rect">
-            <a:avLst/>
-          </a:prstGeom>
-          <a:noFill/>
-        </p:spPr>
-        <p:txBody>
-          <a:bodyPr wrap="square">
-            <a:spAutoFit/>
-          </a:bodyPr>
-          <a:lstStyle/>
-          <a:p>
-            <a:pPr algn="ctr"/>
-            <a:r>
-              <a:rPr sz="1100" b="0">
-                <a:solidFill>
-                  <a:srgbClr val="FFFFFF"/>
-                </a:solidFill>
-              </a:rPr>
-              <a:t>Architect → App → Download</a:t>
-            </a:r>
-          </a:p>
-        </p:txBody>
-      </p:sp>
-      <p:sp>
-        <p:nvSpPr>
-          <p:cNvPr id="16" name="TextBox 15"/>
-          <p:cNvSpPr txBox="1"/>
-          <p:nvPr/>
-        </p:nvSpPr>
-        <p:spPr>
-          <a:xfrm>
-            <a:off x="457200" y="5760720"/>
-            <a:ext cx="10972800" cy="276999"/>
-          </a:xfrm>
-          <a:prstGeom prst="rect">
-            <a:avLst/>
-          </a:prstGeom>
-          <a:noFill/>
-        </p:spPr>
-        <p:txBody>
-          <a:bodyPr wrap="square">
-            <a:spAutoFit/>
-          </a:bodyPr>
-          <a:lstStyle/>
-          <a:p>
-            <a:pPr algn="ctr"/>
-            <a:r>
-              <a:rPr sz="1200" b="0" dirty="0">
+              <a:t>① Every workflow run is logged here with per-node execution trace, total duration, and final status — including an “Awaiting Approval” count with a direct “Review →” link for paused runs.</a:t>
+            </a:r>
+          </a:p>
+          <a:p>
+            <a:pPr>
+              <a:spcAft>
+                <a:spcPts val="400"/>
+              </a:spcAft>
+            </a:pPr>
+            <a:r>
+              <a:rPr sz="1100" dirty="0">
                 <a:solidFill>
                   <a:srgbClr val="CBD5E1"/>
                 </a:solidFill>
               </a:rPr>
-              <a:t> Technology  |  n.sureshmanikandan@accenture.com  |  Confidential</a:t>
-            </a:r>
-          </a:p>
-        </p:txBody>
-      </p:sp>
-      <p:sp>
-        <p:nvSpPr>
-          <p:cNvPr id="17" name="TextBox 16"/>
-          <p:cNvSpPr txBox="1"/>
-          <p:nvPr/>
-        </p:nvSpPr>
-        <p:spPr>
-          <a:xfrm>
-            <a:off x="11640312" y="6492240"/>
-            <a:ext cx="457200" cy="320040"/>
-          </a:xfrm>
-          <a:prstGeom prst="rect">
-            <a:avLst/>
-          </a:prstGeom>
-          <a:noFill/>
-        </p:spPr>
-        <p:txBody>
-          <a:bodyPr wrap="square">
-            <a:spAutoFit/>
-          </a:bodyPr>
-          <a:lstStyle/>
-          <a:p>
-            <a:pPr algn="r"/>
-            <a:r>
-              <a:rPr sz="1100" b="0">
-                <a:solidFill>
-                  <a:srgbClr val="CBD5E1"/>
-                </a:solidFill>
-              </a:rPr>
-              <a:t>37</a:t>
+              <a:t>② Backed by real Open Telemetry spans on every LLM call, so a slow or failed run can be traced back to the exact node, prompt, and latency that caused it — not a black box.</a:t>
             </a:r>
           </a:p>
         </p:txBody>
@@ -42174,6 +42314,635 @@
 </file>
 
 <file path=ppt/slides/slide45.xml><?xml version="1.0" encoding="utf-8"?>
+<p:sld xmlns:a="http://schemas.openxmlformats.org/drawingml/2006/main" xmlns:r="http://schemas.openxmlformats.org/officeDocument/2006/relationships" xmlns:p="http://schemas.openxmlformats.org/presentationml/2006/main">
+  <p:cSld>
+    <p:spTree>
+      <p:nvGrpSpPr>
+        <p:cNvPr id="1" name=""/>
+        <p:cNvGrpSpPr/>
+        <p:nvPr/>
+      </p:nvGrpSpPr>
+      <p:grpSpPr>
+        <a:xfrm>
+          <a:off x="0" y="0"/>
+          <a:ext cx="0" cy="0"/>
+          <a:chOff x="0" y="0"/>
+          <a:chExt cx="0" cy="0"/>
+        </a:xfrm>
+      </p:grpSpPr>
+      <p:sp>
+        <p:nvSpPr>
+          <p:cNvPr id="2" name="Rectangle 1"/>
+          <p:cNvSpPr/>
+          <p:nvPr/>
+        </p:nvSpPr>
+        <p:spPr>
+          <a:xfrm>
+            <a:off x="0" y="0"/>
+            <a:ext cx="12188952" cy="6858000"/>
+          </a:xfrm>
+          <a:prstGeom prst="rect">
+            <a:avLst/>
+          </a:prstGeom>
+          <a:solidFill>
+            <a:srgbClr val="0F172A"/>
+          </a:solidFill>
+          <a:ln>
+            <a:noFill/>
+          </a:ln>
+        </p:spPr>
+        <p:style>
+          <a:lnRef idx="1">
+            <a:schemeClr val="accent1"/>
+          </a:lnRef>
+          <a:fillRef idx="3">
+            <a:schemeClr val="accent1"/>
+          </a:fillRef>
+          <a:effectRef idx="2">
+            <a:schemeClr val="accent1"/>
+          </a:effectRef>
+          <a:fontRef idx="minor">
+            <a:schemeClr val="lt1"/>
+          </a:fontRef>
+        </p:style>
+        <p:txBody>
+          <a:bodyPr rtlCol="0" anchor="ctr"/>
+          <a:lstStyle/>
+          <a:p>
+            <a:pPr algn="ctr"/>
+            <a:endParaRPr/>
+          </a:p>
+        </p:txBody>
+      </p:sp>
+      <p:sp>
+        <p:nvSpPr>
+          <p:cNvPr id="3" name="Rectangle 2"/>
+          <p:cNvSpPr/>
+          <p:nvPr/>
+        </p:nvSpPr>
+        <p:spPr>
+          <a:xfrm>
+            <a:off x="0" y="0"/>
+            <a:ext cx="12188952" cy="45720"/>
+          </a:xfrm>
+          <a:prstGeom prst="rect">
+            <a:avLst/>
+          </a:prstGeom>
+          <a:solidFill>
+            <a:srgbClr val="606EF5"/>
+          </a:solidFill>
+          <a:ln>
+            <a:noFill/>
+          </a:ln>
+        </p:spPr>
+        <p:style>
+          <a:lnRef idx="1">
+            <a:schemeClr val="accent1"/>
+          </a:lnRef>
+          <a:fillRef idx="3">
+            <a:schemeClr val="accent1"/>
+          </a:fillRef>
+          <a:effectRef idx="2">
+            <a:schemeClr val="accent1"/>
+          </a:effectRef>
+          <a:fontRef idx="minor">
+            <a:schemeClr val="lt1"/>
+          </a:fontRef>
+        </p:style>
+        <p:txBody>
+          <a:bodyPr rtlCol="0" anchor="ctr"/>
+          <a:lstStyle/>
+          <a:p>
+            <a:pPr algn="ctr"/>
+            <a:endParaRPr/>
+          </a:p>
+        </p:txBody>
+      </p:sp>
+      <p:sp>
+        <p:nvSpPr>
+          <p:cNvPr id="4" name="Rectangle 3"/>
+          <p:cNvSpPr/>
+          <p:nvPr/>
+        </p:nvSpPr>
+        <p:spPr>
+          <a:xfrm>
+            <a:off x="0" y="1371600"/>
+            <a:ext cx="12188952" cy="4114800"/>
+          </a:xfrm>
+          <a:prstGeom prst="rect">
+            <a:avLst/>
+          </a:prstGeom>
+          <a:solidFill>
+            <a:srgbClr val="1A243E"/>
+          </a:solidFill>
+          <a:ln>
+            <a:noFill/>
+          </a:ln>
+        </p:spPr>
+        <p:style>
+          <a:lnRef idx="1">
+            <a:schemeClr val="accent1"/>
+          </a:lnRef>
+          <a:fillRef idx="3">
+            <a:schemeClr val="accent1"/>
+          </a:fillRef>
+          <a:effectRef idx="2">
+            <a:schemeClr val="accent1"/>
+          </a:effectRef>
+          <a:fontRef idx="minor">
+            <a:schemeClr val="lt1"/>
+          </a:fontRef>
+        </p:style>
+        <p:txBody>
+          <a:bodyPr rtlCol="0" anchor="ctr"/>
+          <a:lstStyle/>
+          <a:p>
+            <a:pPr algn="ctr"/>
+            <a:endParaRPr/>
+          </a:p>
+        </p:txBody>
+      </p:sp>
+      <p:sp>
+        <p:nvSpPr>
+          <p:cNvPr id="5" name="TextBox 4"/>
+          <p:cNvSpPr txBox="1"/>
+          <p:nvPr/>
+        </p:nvSpPr>
+        <p:spPr>
+          <a:xfrm>
+            <a:off x="457200" y="1645920"/>
+            <a:ext cx="10972800" cy="914400"/>
+          </a:xfrm>
+          <a:prstGeom prst="rect">
+            <a:avLst/>
+          </a:prstGeom>
+          <a:noFill/>
+        </p:spPr>
+        <p:txBody>
+          <a:bodyPr wrap="square">
+            <a:spAutoFit/>
+          </a:bodyPr>
+          <a:lstStyle/>
+          <a:p>
+            <a:pPr algn="ctr"/>
+            <a:r>
+              <a:rPr sz="5400" b="1">
+                <a:solidFill>
+                  <a:srgbClr val="FFFFFF"/>
+                </a:solidFill>
+              </a:rPr>
+              <a:t>AgentForge</a:t>
+            </a:r>
+          </a:p>
+        </p:txBody>
+      </p:sp>
+      <p:sp>
+        <p:nvSpPr>
+          <p:cNvPr id="6" name="TextBox 5"/>
+          <p:cNvSpPr txBox="1"/>
+          <p:nvPr/>
+        </p:nvSpPr>
+        <p:spPr>
+          <a:xfrm>
+            <a:off x="457200" y="2606040"/>
+            <a:ext cx="10972800" cy="731520"/>
+          </a:xfrm>
+          <a:prstGeom prst="rect">
+            <a:avLst/>
+          </a:prstGeom>
+          <a:noFill/>
+        </p:spPr>
+        <p:txBody>
+          <a:bodyPr wrap="square">
+            <a:spAutoFit/>
+          </a:bodyPr>
+          <a:lstStyle/>
+          <a:p>
+            <a:pPr algn="ctr"/>
+            <a:r>
+              <a:rPr sz="2200" b="0">
+                <a:solidFill>
+                  <a:srgbClr val="CBD5E1"/>
+                </a:solidFill>
+              </a:rPr>
+              <a:t>Build the next generation of enterprise AI agents — today.</a:t>
+            </a:r>
+          </a:p>
+        </p:txBody>
+      </p:sp>
+      <p:sp>
+        <p:nvSpPr>
+          <p:cNvPr id="7" name="Rectangle 6"/>
+          <p:cNvSpPr/>
+          <p:nvPr/>
+        </p:nvSpPr>
+        <p:spPr>
+          <a:xfrm>
+            <a:off x="1371600" y="3657600"/>
+            <a:ext cx="2834640" cy="777240"/>
+          </a:xfrm>
+          <a:prstGeom prst="rect">
+            <a:avLst/>
+          </a:prstGeom>
+          <a:solidFill>
+            <a:srgbClr val="606EF5"/>
+          </a:solidFill>
+          <a:ln>
+            <a:noFill/>
+          </a:ln>
+        </p:spPr>
+        <p:style>
+          <a:lnRef idx="1">
+            <a:schemeClr val="accent1"/>
+          </a:lnRef>
+          <a:fillRef idx="3">
+            <a:schemeClr val="accent1"/>
+          </a:fillRef>
+          <a:effectRef idx="2">
+            <a:schemeClr val="accent1"/>
+          </a:effectRef>
+          <a:fontRef idx="minor">
+            <a:schemeClr val="lt1"/>
+          </a:fontRef>
+        </p:style>
+        <p:txBody>
+          <a:bodyPr rtlCol="0" anchor="ctr"/>
+          <a:lstStyle/>
+          <a:p>
+            <a:pPr algn="ctr"/>
+            <a:endParaRPr/>
+          </a:p>
+        </p:txBody>
+      </p:sp>
+      <p:sp>
+        <p:nvSpPr>
+          <p:cNvPr id="8" name="TextBox 7"/>
+          <p:cNvSpPr txBox="1"/>
+          <p:nvPr/>
+        </p:nvSpPr>
+        <p:spPr>
+          <a:xfrm>
+            <a:off x="1371600" y="3703320"/>
+            <a:ext cx="2834640" cy="384048"/>
+          </a:xfrm>
+          <a:prstGeom prst="rect">
+            <a:avLst/>
+          </a:prstGeom>
+          <a:noFill/>
+        </p:spPr>
+        <p:txBody>
+          <a:bodyPr wrap="square">
+            <a:spAutoFit/>
+          </a:bodyPr>
+          <a:lstStyle/>
+          <a:p>
+            <a:pPr algn="ctr"/>
+            <a:r>
+              <a:rPr sz="1400" b="1">
+                <a:solidFill>
+                  <a:srgbClr val="FFFFFF"/>
+                </a:solidFill>
+              </a:rPr>
+              <a:t>🚀  Start Building</a:t>
+            </a:r>
+          </a:p>
+        </p:txBody>
+      </p:sp>
+      <p:sp>
+        <p:nvSpPr>
+          <p:cNvPr id="9" name="TextBox 8"/>
+          <p:cNvSpPr txBox="1"/>
+          <p:nvPr/>
+        </p:nvSpPr>
+        <p:spPr>
+          <a:xfrm>
+            <a:off x="1371600" y="4087368"/>
+            <a:ext cx="2834640" cy="320040"/>
+          </a:xfrm>
+          <a:prstGeom prst="rect">
+            <a:avLst/>
+          </a:prstGeom>
+          <a:noFill/>
+        </p:spPr>
+        <p:txBody>
+          <a:bodyPr wrap="square">
+            <a:spAutoFit/>
+          </a:bodyPr>
+          <a:lstStyle/>
+          <a:p>
+            <a:pPr algn="ctr"/>
+            <a:r>
+              <a:rPr sz="1100" b="0">
+                <a:solidFill>
+                  <a:srgbClr val="FFFFFF"/>
+                </a:solidFill>
+              </a:rPr>
+              <a:t>localhost:5173/architect</a:t>
+            </a:r>
+          </a:p>
+        </p:txBody>
+      </p:sp>
+      <p:sp>
+        <p:nvSpPr>
+          <p:cNvPr id="10" name="Rectangle 9"/>
+          <p:cNvSpPr/>
+          <p:nvPr/>
+        </p:nvSpPr>
+        <p:spPr>
+          <a:xfrm>
+            <a:off x="4572000" y="3657600"/>
+            <a:ext cx="2834640" cy="777240"/>
+          </a:xfrm>
+          <a:prstGeom prst="rect">
+            <a:avLst/>
+          </a:prstGeom>
+          <a:solidFill>
+            <a:srgbClr val="10B981"/>
+          </a:solidFill>
+          <a:ln>
+            <a:noFill/>
+          </a:ln>
+        </p:spPr>
+        <p:style>
+          <a:lnRef idx="1">
+            <a:schemeClr val="accent1"/>
+          </a:lnRef>
+          <a:fillRef idx="3">
+            <a:schemeClr val="accent1"/>
+          </a:fillRef>
+          <a:effectRef idx="2">
+            <a:schemeClr val="accent1"/>
+          </a:effectRef>
+          <a:fontRef idx="minor">
+            <a:schemeClr val="lt1"/>
+          </a:fontRef>
+        </p:style>
+        <p:txBody>
+          <a:bodyPr rtlCol="0" anchor="ctr"/>
+          <a:lstStyle/>
+          <a:p>
+            <a:pPr algn="ctr"/>
+            <a:endParaRPr/>
+          </a:p>
+        </p:txBody>
+      </p:sp>
+      <p:sp>
+        <p:nvSpPr>
+          <p:cNvPr id="11" name="TextBox 10"/>
+          <p:cNvSpPr txBox="1"/>
+          <p:nvPr/>
+        </p:nvSpPr>
+        <p:spPr>
+          <a:xfrm>
+            <a:off x="4572000" y="3703320"/>
+            <a:ext cx="2834640" cy="384048"/>
+          </a:xfrm>
+          <a:prstGeom prst="rect">
+            <a:avLst/>
+          </a:prstGeom>
+          <a:noFill/>
+        </p:spPr>
+        <p:txBody>
+          <a:bodyPr wrap="square">
+            <a:spAutoFit/>
+          </a:bodyPr>
+          <a:lstStyle/>
+          <a:p>
+            <a:pPr algn="ctr"/>
+            <a:r>
+              <a:rPr sz="1400" b="1">
+                <a:solidFill>
+                  <a:srgbClr val="FFFFFF"/>
+                </a:solidFill>
+              </a:rPr>
+              <a:t>📖  API Docs</a:t>
+            </a:r>
+          </a:p>
+        </p:txBody>
+      </p:sp>
+      <p:sp>
+        <p:nvSpPr>
+          <p:cNvPr id="12" name="TextBox 11"/>
+          <p:cNvSpPr txBox="1"/>
+          <p:nvPr/>
+        </p:nvSpPr>
+        <p:spPr>
+          <a:xfrm>
+            <a:off x="4572000" y="4087368"/>
+            <a:ext cx="2834640" cy="320040"/>
+          </a:xfrm>
+          <a:prstGeom prst="rect">
+            <a:avLst/>
+          </a:prstGeom>
+          <a:noFill/>
+        </p:spPr>
+        <p:txBody>
+          <a:bodyPr wrap="square">
+            <a:spAutoFit/>
+          </a:bodyPr>
+          <a:lstStyle/>
+          <a:p>
+            <a:pPr algn="ctr"/>
+            <a:r>
+              <a:rPr sz="1100" b="0">
+                <a:solidFill>
+                  <a:srgbClr val="FFFFFF"/>
+                </a:solidFill>
+              </a:rPr>
+              <a:t>localhost:8000/docs</a:t>
+            </a:r>
+          </a:p>
+        </p:txBody>
+      </p:sp>
+      <p:sp>
+        <p:nvSpPr>
+          <p:cNvPr id="13" name="Rectangle 12"/>
+          <p:cNvSpPr/>
+          <p:nvPr/>
+        </p:nvSpPr>
+        <p:spPr>
+          <a:xfrm>
+            <a:off x="7772400" y="3657600"/>
+            <a:ext cx="2834640" cy="777240"/>
+          </a:xfrm>
+          <a:prstGeom prst="rect">
+            <a:avLst/>
+          </a:prstGeom>
+          <a:solidFill>
+            <a:srgbClr val="F59E0B"/>
+          </a:solidFill>
+          <a:ln>
+            <a:noFill/>
+          </a:ln>
+        </p:spPr>
+        <p:style>
+          <a:lnRef idx="1">
+            <a:schemeClr val="accent1"/>
+          </a:lnRef>
+          <a:fillRef idx="3">
+            <a:schemeClr val="accent1"/>
+          </a:fillRef>
+          <a:effectRef idx="2">
+            <a:schemeClr val="accent1"/>
+          </a:effectRef>
+          <a:fontRef idx="minor">
+            <a:schemeClr val="lt1"/>
+          </a:fontRef>
+        </p:style>
+        <p:txBody>
+          <a:bodyPr rtlCol="0" anchor="ctr"/>
+          <a:lstStyle/>
+          <a:p>
+            <a:pPr algn="ctr"/>
+            <a:endParaRPr/>
+          </a:p>
+        </p:txBody>
+      </p:sp>
+      <p:sp>
+        <p:nvSpPr>
+          <p:cNvPr id="14" name="TextBox 13"/>
+          <p:cNvSpPr txBox="1"/>
+          <p:nvPr/>
+        </p:nvSpPr>
+        <p:spPr>
+          <a:xfrm>
+            <a:off x="7772400" y="3703320"/>
+            <a:ext cx="2834640" cy="384048"/>
+          </a:xfrm>
+          <a:prstGeom prst="rect">
+            <a:avLst/>
+          </a:prstGeom>
+          <a:noFill/>
+        </p:spPr>
+        <p:txBody>
+          <a:bodyPr wrap="square">
+            <a:spAutoFit/>
+          </a:bodyPr>
+          <a:lstStyle/>
+          <a:p>
+            <a:pPr algn="ctr"/>
+            <a:r>
+              <a:rPr sz="1400" b="1">
+                <a:solidFill>
+                  <a:srgbClr val="FFFFFF"/>
+                </a:solidFill>
+              </a:rPr>
+              <a:t>📦  Download ZIP</a:t>
+            </a:r>
+          </a:p>
+        </p:txBody>
+      </p:sp>
+      <p:sp>
+        <p:nvSpPr>
+          <p:cNvPr id="15" name="TextBox 14"/>
+          <p:cNvSpPr txBox="1"/>
+          <p:nvPr/>
+        </p:nvSpPr>
+        <p:spPr>
+          <a:xfrm>
+            <a:off x="7772400" y="4087368"/>
+            <a:ext cx="2834640" cy="320040"/>
+          </a:xfrm>
+          <a:prstGeom prst="rect">
+            <a:avLst/>
+          </a:prstGeom>
+          <a:noFill/>
+        </p:spPr>
+        <p:txBody>
+          <a:bodyPr wrap="square">
+            <a:spAutoFit/>
+          </a:bodyPr>
+          <a:lstStyle/>
+          <a:p>
+            <a:pPr algn="ctr"/>
+            <a:r>
+              <a:rPr sz="1100" b="0">
+                <a:solidFill>
+                  <a:srgbClr val="FFFFFF"/>
+                </a:solidFill>
+              </a:rPr>
+              <a:t>Architect → App → Download</a:t>
+            </a:r>
+          </a:p>
+        </p:txBody>
+      </p:sp>
+      <p:sp>
+        <p:nvSpPr>
+          <p:cNvPr id="16" name="TextBox 15"/>
+          <p:cNvSpPr txBox="1"/>
+          <p:nvPr/>
+        </p:nvSpPr>
+        <p:spPr>
+          <a:xfrm>
+            <a:off x="457200" y="5760720"/>
+            <a:ext cx="10972800" cy="276999"/>
+          </a:xfrm>
+          <a:prstGeom prst="rect">
+            <a:avLst/>
+          </a:prstGeom>
+          <a:noFill/>
+        </p:spPr>
+        <p:txBody>
+          <a:bodyPr wrap="square">
+            <a:spAutoFit/>
+          </a:bodyPr>
+          <a:lstStyle/>
+          <a:p>
+            <a:pPr algn="ctr"/>
+            <a:r>
+              <a:rPr sz="1200" b="0" dirty="0">
+                <a:solidFill>
+                  <a:srgbClr val="CBD5E1"/>
+                </a:solidFill>
+              </a:rPr>
+              <a:t> Technology  |  n.sureshmanikandan@accenture.com  |  Confidential</a:t>
+            </a:r>
+          </a:p>
+        </p:txBody>
+      </p:sp>
+      <p:sp>
+        <p:nvSpPr>
+          <p:cNvPr id="17" name="TextBox 16"/>
+          <p:cNvSpPr txBox="1"/>
+          <p:nvPr/>
+        </p:nvSpPr>
+        <p:spPr>
+          <a:xfrm>
+            <a:off x="11640312" y="6492240"/>
+            <a:ext cx="457200" cy="320040"/>
+          </a:xfrm>
+          <a:prstGeom prst="rect">
+            <a:avLst/>
+          </a:prstGeom>
+          <a:noFill/>
+        </p:spPr>
+        <p:txBody>
+          <a:bodyPr wrap="square">
+            <a:spAutoFit/>
+          </a:bodyPr>
+          <a:lstStyle/>
+          <a:p>
+            <a:pPr algn="r"/>
+            <a:r>
+              <a:rPr sz="1100" b="0">
+                <a:solidFill>
+                  <a:srgbClr val="CBD5E1"/>
+                </a:solidFill>
+              </a:rPr>
+              <a:t>37</a:t>
+            </a:r>
+          </a:p>
+        </p:txBody>
+      </p:sp>
+    </p:spTree>
+  </p:cSld>
+  <p:clrMapOvr>
+    <a:masterClrMapping/>
+  </p:clrMapOvr>
+</p:sld>
+</file>
+
+<file path=ppt/slides/slide46.xml><?xml version="1.0" encoding="utf-8"?>
 <p:sld xmlns:a="http://schemas.openxmlformats.org/drawingml/2006/main" xmlns:p="http://schemas.openxmlformats.org/presentationml/2006/main" xmlns:r="http://schemas.openxmlformats.org/officeDocument/2006/relationships">
   <p:cSld>
     <p:spTree>
@@ -42203,7 +42972,6 @@
           <a:ln>
             <a:noFill/>
           </a:ln>
-          <a:effectLst/>
         </p:spPr>
         <p:style>
           <a:lnRef idx="1">
@@ -42224,6 +42992,7 @@
           <a:lstStyle/>
           <a:p>
             <a:pPr algn="ctr"/>
+            <a:endParaRPr/>
           </a:p>
         </p:txBody>
       </p:sp>
@@ -42247,7 +43016,6 @@
           <a:ln>
             <a:noFill/>
           </a:ln>
-          <a:effectLst/>
         </p:spPr>
         <p:style>
           <a:lnRef idx="1">
@@ -42268,6 +43036,7 @@
           <a:lstStyle/>
           <a:p>
             <a:pPr algn="ctr"/>
+            <a:endParaRPr/>
           </a:p>
         </p:txBody>
       </p:sp>
@@ -42295,12 +43064,12 @@
           <a:p>
             <a:pPr algn="l"/>
             <a:r>
-              <a:rPr sz="2400" b="1">
+              <a:rPr sz="2600" b="1">
                 <a:solidFill>
                   <a:srgbClr val="FFFFFF"/>
                 </a:solidFill>
               </a:rPr>
-              <a:t>Honest UI Audit &amp; a Real Production Bug — What Changed</a:t>
+              <a:t>Latest Platform Updates — Gemini Provider &amp; RAG Overhaul</a:t>
             </a:r>
           </a:p>
         </p:txBody>
@@ -42329,12 +43098,12 @@
           <a:p>
             <a:pPr algn="l"/>
             <a:r>
-              <a:rPr sz="1200" b="0">
+              <a:rPr sz="1300" b="0">
                 <a:solidFill>
                   <a:srgbClr val="CBD5E1"/>
                 </a:solidFill>
               </a:rPr>
-              <a:t>A page-by-page pass asking “is this actually wired to the backend, or does it just look like it is?” — found three independent fake integration surfaces, a fully non-functional publish loop, and one genuine crash silently zeroing out two dashboards.</a:t>
+              <a:t>This pass added Google Gemini as a genuine third LLM provider and rewrote the RAG pipeline on real vector search — both verified live against running Azure OpenAI, Gemini, and Postgres instances, not just unit tests.</a:t>
             </a:r>
           </a:p>
         </p:txBody>
@@ -42359,7 +43128,6 @@
           <a:ln>
             <a:noFill/>
           </a:ln>
-          <a:effectLst/>
         </p:spPr>
         <p:style>
           <a:lnRef idx="1">
@@ -42380,6 +43148,7 @@
           <a:lstStyle/>
           <a:p>
             <a:pPr algn="ctr"/>
+            <a:endParaRPr/>
           </a:p>
         </p:txBody>
       </p:sp>
@@ -42412,7 +43181,7 @@
                   <a:srgbClr val="606EF5"/>
                 </a:solidFill>
               </a:rPr>
-              <a:t>🎯  Deterministic Branch Input Matching</a:t>
+              <a:t>🌐  Google Gemini as a Third Provider</a:t>
             </a:r>
           </a:p>
         </p:txBody>
@@ -42425,7 +43194,7 @@
         </p:nvSpPr>
         <p:spPr>
           <a:xfrm>
-            <a:off x="594360" y="1920303"/>
+            <a:off x="594360" y="1920240"/>
             <a:ext cx="11064240" cy="457200"/>
           </a:xfrm>
           <a:prstGeom prst="rect">
@@ -42441,12 +43210,12 @@
           <a:p>
             <a:pPr algn="l"/>
             <a:r>
-              <a:rPr sz="1050" b="0">
+              <a:rPr sz="1100" b="0">
                 <a:solidFill>
                   <a:srgbClr val="CBD5E1"/>
                 </a:solidFill>
               </a:rPr>
-              <a:t>The Run modal's example input now regenerates to match whichever router branch is force-selected (e.g. Critical vs Routine) instead of leaving a stale, narratively mismatched example — a new target_label parameter on /suggest-input asks the LLM to write an example that specifically satisfies that router node's own classification criteria.</a:t>
+              <a:t>Chat, RAG answers, and voice can now run on Gemini via the google-genai SDK (API-key or Vertex AI + ADC) — a genuine third option alongside Azure OpenAI and local LM Studio.</a:t>
             </a:r>
           </a:p>
         </p:txBody>
@@ -42471,7 +43240,6 @@
           <a:ln>
             <a:noFill/>
           </a:ln>
-          <a:effectLst/>
         </p:spPr>
         <p:style>
           <a:lnRef idx="1">
@@ -42492,6 +43260,7 @@
           <a:lstStyle/>
           <a:p>
             <a:pPr algn="ctr"/>
+            <a:endParaRPr/>
           </a:p>
         </p:txBody>
       </p:sp>
@@ -42524,7 +43293,7 @@
                   <a:srgbClr val="606EF5"/>
                 </a:solidFill>
               </a:rPr>
-              <a:t>🏷️  Found: 3 Independent Fake “Connect a Tool” Surfaces</a:t>
+              <a:t>🔀  Per-Feature Provider Overrides</a:t>
             </a:r>
           </a:p>
         </p:txBody>
@@ -42537,7 +43306,7 @@
         </p:nvSpPr>
         <p:spPr>
           <a:xfrm>
-            <a:off x="594360" y="2816415"/>
+            <a:off x="594360" y="2816352"/>
             <a:ext cx="11064240" cy="457200"/>
           </a:xfrm>
           <a:prstGeom prst="rect">
@@ -42553,12 +43322,12 @@
           <a:p>
             <a:pPr algn="l"/>
             <a:r>
-              <a:rPr sz="1050" b="0">
+              <a:rPr sz="1100" b="0">
                 <a:solidFill>
                   <a:srgbClr val="CBD5E1"/>
                 </a:solidFill>
               </a:rPr>
-              <a:t>Home's Connect modal, Marketplace's Tool Integrations tab, and Agent Studio's tool checkboxes each silently did nothing — three separate, unsynchronized implementations of the same idea, none wired to any real OAuth flow or API credential. All three now carry an honest “not yet active” label instead of implying real access.</a:t>
+              <a:t>ARCHITECT_LLM_PROVIDER and BUILDER_LLM_PROVIDER let Architect and everything else run on different providers independently — Architect code-gen and RAG embeddings stay pinned to Azure regardless of the chat provider.</a:t>
             </a:r>
           </a:p>
         </p:txBody>
@@ -42571,7 +43340,7 @@
         </p:nvSpPr>
         <p:spPr>
           <a:xfrm>
-            <a:off x="365760" y="3328416"/>
+            <a:off x="365760" y="3328415"/>
             <a:ext cx="73152" cy="777240"/>
           </a:xfrm>
           <a:prstGeom prst="rect">
@@ -42583,7 +43352,6 @@
           <a:ln>
             <a:noFill/>
           </a:ln>
-          <a:effectLst/>
         </p:spPr>
         <p:style>
           <a:lnRef idx="1">
@@ -42604,6 +43372,7 @@
           <a:lstStyle/>
           <a:p>
             <a:pPr algn="ctr"/>
+            <a:endParaRPr/>
           </a:p>
         </p:txBody>
       </p:sp>
@@ -42615,7 +43384,7 @@
         </p:nvSpPr>
         <p:spPr>
           <a:xfrm>
-            <a:off x="594360" y="3346704"/>
+            <a:off x="594360" y="3346703"/>
             <a:ext cx="10972800" cy="365760"/>
           </a:xfrm>
           <a:prstGeom prst="rect">
@@ -42636,7 +43405,7 @@
                   <a:srgbClr val="606EF5"/>
                 </a:solidFill>
               </a:rPr>
-              <a:t>🗑️  Retired the Publish → Marketplace → Install Loop</a:t>
+              <a:t>📚  Real FAISS Vector Search</a:t>
             </a:r>
           </a:p>
         </p:txBody>
@@ -42649,7 +43418,7 @@
         </p:nvSpPr>
         <p:spPr>
           <a:xfrm>
-            <a:off x="594360" y="3712527"/>
+            <a:off x="594360" y="3712463"/>
             <a:ext cx="11064240" cy="457200"/>
           </a:xfrm>
           <a:prstGeom prst="rect">
@@ -42665,12 +43434,12 @@
           <a:p>
             <a:pPr algn="l"/>
             <a:r>
-              <a:rPr sz="1050" b="0">
+              <a:rPr sz="1100" b="0">
                 <a:solidFill>
                   <a:srgbClr val="CBD5E1"/>
                 </a:solidFill>
               </a:rPr>
-              <a:t>Agent Studio's “Publish to Marketplace” button and Marketplace's “Published Agents” tab formed a closed, browser-local loop — both read/wrote the same localStorage key, never touched the backend, and shared nothing across users or even across browsers on the same machine. Removed entirely rather than left half-working.</a:t>
+              <a:t>Each knowledge base now gets its own FAISS IndexFlatIP index built from real Azure OpenAI embeddings, with structure-aware DOCX chunking and a real chunks table — replacing the prior naive in-memory RAG.</a:t>
             </a:r>
           </a:p>
         </p:txBody>
@@ -42695,7 +43464,6 @@
           <a:ln>
             <a:noFill/>
           </a:ln>
-          <a:effectLst/>
         </p:spPr>
         <p:style>
           <a:lnRef idx="1">
@@ -42716,6 +43484,7 @@
           <a:lstStyle/>
           <a:p>
             <a:pPr algn="ctr"/>
+            <a:endParaRPr/>
           </a:p>
         </p:txBody>
       </p:sp>
@@ -42748,7 +43517,7 @@
                   <a:srgbClr val="606EF5"/>
                 </a:solidFill>
               </a:rPr>
-              <a:t>🐛  Fixed: Control Plane &amp; Usage Showing Zero</a:t>
+              <a:t>🔁  Upsert, List &amp; Delete</a:t>
             </a:r>
           </a:p>
         </p:txBody>
@@ -42761,7 +43530,7 @@
         </p:nvSpPr>
         <p:spPr>
           <a:xfrm>
-            <a:off x="594360" y="4608639"/>
+            <a:off x="594360" y="4608576"/>
             <a:ext cx="11064240" cy="457200"/>
           </a:xfrm>
           <a:prstGeom prst="rect">
@@ -42777,12 +43546,12 @@
           <a:p>
             <a:pPr algn="l"/>
             <a:r>
-              <a:rPr sz="1050" b="0">
+              <a:rPr sz="1100" b="0">
                 <a:solidFill>
                   <a:srgbClr val="CBD5E1"/>
                 </a:solidFill>
               </a:rPr>
-              <a:t>/api/control-plane/stats was silently crashing with a 500 — Postgres returns a float for one average and a Decimal for another, and adding them raised a TypeError. Both dashboards swallowed the error and showed 0/blank stat cards despite real data sitting in the tables directly below them. Cast both averages to float; verified live with real numbers (4 agents, 7 genuine runs).</a:t>
+              <a:t>Re-uploading a file with the same name replaces its old chunks instead of duplicating them; new endpoints list every KB, fetch one with its documents, and delete a KB and its index cleanly.</a:t>
             </a:r>
           </a:p>
         </p:txBody>
@@ -42807,7 +43576,6 @@
           <a:ln>
             <a:noFill/>
           </a:ln>
-          <a:effectLst/>
         </p:spPr>
         <p:style>
           <a:lnRef idx="1">
@@ -42828,6 +43596,7 @@
           <a:lstStyle/>
           <a:p>
             <a:pPr algn="ctr"/>
+            <a:endParaRPr/>
           </a:p>
         </p:txBody>
       </p:sp>
@@ -42860,7 +43629,7 @@
                   <a:srgbClr val="606EF5"/>
                 </a:solidFill>
               </a:rPr>
-              <a:t>🧹  Sidebar Naming Consistency</a:t>
+              <a:t>💡  Suggested Questions &amp; Agent Linkage</a:t>
             </a:r>
           </a:p>
         </p:txBody>
@@ -42873,7 +43642,7 @@
         </p:nvSpPr>
         <p:spPr>
           <a:xfrm>
-            <a:off x="594360" y="5504751"/>
+            <a:off x="594360" y="5504688"/>
             <a:ext cx="11064240" cy="457200"/>
           </a:xfrm>
           <a:prstGeom prst="rect">
@@ -42889,12 +43658,12 @@
           <a:p>
             <a:pPr algn="l"/>
             <a:r>
-              <a:rPr sz="1050" b="0">
+              <a:rPr sz="1100" b="0">
                 <a:solidFill>
                   <a:srgbClr val="CBD5E1"/>
                 </a:solidFill>
               </a:rPr>
-              <a:t>Sidebar labels now match each page's own on-page title exactly instead of drifting from it — closing a three-way mismatch between the nav label, the page's own heading, and the route/filename that made it unclear which page you'd actually land on.</a:t>
+              <a:t>A new endpoint generates real, ready-to-ask questions straight from a KB's own indexed content, and any knowledge base can now be linked directly to an agent for automatic retrieval on every run.</a:t>
             </a:r>
           </a:p>
         </p:txBody>
@@ -42921,14 +43690,14 @@
           </a:bodyPr>
           <a:lstStyle/>
           <a:p>
-            <a:pPr algn="l"/>
+            <a:pPr algn="r"/>
             <a:r>
               <a:rPr sz="1100" b="0">
                 <a:solidFill>
                   <a:srgbClr val="CBD5E1"/>
                 </a:solidFill>
               </a:rPr>
-              <a:t>35a</a:t>
+              <a:t>26a</a:t>
             </a:r>
           </a:p>
         </p:txBody>

</xml_diff>